<commit_message>
feat: implement multiple pickers simulation, congestion modeling, and update poster assets
</commit_message>
<xml_diff>
--- a/ElectroSolve_2026_Warehouse_Digital_Twin.pptx
+++ b/ElectroSolve_2026_Warehouse_Digital_Twin.pptx
@@ -16,6 +16,7 @@
     <p:sldId id="264" r:id="rId16"/>
     <p:sldId id="265" r:id="rId17"/>
     <p:sldId id="266" r:id="rId18"/>
+    <p:sldId id="267" r:id="rId19"/>
   </p:sldIdLst>
   <p:sldSz cx="12191695" cy="6858000" type="screen4x3"/>
   <p:notesSz cx="6858000" cy="9144000"/>
@@ -115,6 +116,413 @@
     </a:lvl9pPr>
   </p:defaultTextStyle>
 </p:presentation>
+</file>
+
+<file path=ppt/charts/chart1.xml><?xml version="1.0" encoding="utf-8"?>
+<c:chartSpace xmlns:c="http://schemas.openxmlformats.org/drawingml/2006/chart" xmlns:a="http://schemas.openxmlformats.org/drawingml/2006/main" xmlns:r="http://schemas.openxmlformats.org/officeDocument/2006/relationships">
+  <c:date1904 val="0"/>
+  <c:chart>
+    <c:autoTitleDeleted val="0"/>
+    <c:plotArea>
+      <c:lineChart>
+        <c:grouping val="standard"/>
+        <c:varyColors val="0"/>
+        <c:ser>
+          <c:idx val="0"/>
+          <c:order val="0"/>
+          <c:tx>
+            <c:strRef>
+              <c:f>Sheet1!$B$1</c:f>
+              <c:strCache>
+                <c:ptCount val="1"/>
+                <c:pt idx="0">
+                  <c:v>Perfect scaling</c:v>
+                </c:pt>
+              </c:strCache>
+            </c:strRef>
+          </c:tx>
+          <c:spPr>
+            <a:ln w="28575">
+              <a:solidFill>
+                <a:srgbClr val="7D786C"/>
+              </a:solidFill>
+              <a:prstDash val="dash"/>
+            </a:ln>
+          </c:spPr>
+          <c:marker>
+            <c:symbol val="circle"/>
+            <c:size val="6"/>
+            <c:spPr>
+              <a:solidFill>
+                <a:srgbClr val="7D786C"/>
+              </a:solidFill>
+              <a:ln>
+                <a:solidFill>
+                  <a:srgbClr val="7D786C"/>
+                </a:solidFill>
+              </a:ln>
+            </c:spPr>
+          </c:marker>
+          <c:cat>
+            <c:strRef>
+              <c:f>Sheet1!$A$2:$A$7</c:f>
+              <c:strCache>
+                <c:ptCount val="6"/>
+                <c:pt idx="0">
+                  <c:v>1</c:v>
+                </c:pt>
+                <c:pt idx="1">
+                  <c:v>2</c:v>
+                </c:pt>
+                <c:pt idx="2">
+                  <c:v>3</c:v>
+                </c:pt>
+                <c:pt idx="3">
+                  <c:v>4</c:v>
+                </c:pt>
+                <c:pt idx="4">
+                  <c:v>5</c:v>
+                </c:pt>
+                <c:pt idx="5">
+                  <c:v>6</c:v>
+                </c:pt>
+              </c:strCache>
+            </c:strRef>
+          </c:cat>
+          <c:val>
+            <c:numRef>
+              <c:f>Sheet1!$B$2:$B$7</c:f>
+              <c:numCache>
+                <c:formatCode>General</c:formatCode>
+                <c:ptCount val="6"/>
+                <c:pt idx="0">
+                  <c:v>26.2</c:v>
+                </c:pt>
+                <c:pt idx="1">
+                  <c:v>52.4</c:v>
+                </c:pt>
+                <c:pt idx="2">
+                  <c:v>78.5</c:v>
+                </c:pt>
+                <c:pt idx="3">
+                  <c:v>104.7</c:v>
+                </c:pt>
+                <c:pt idx="4">
+                  <c:v>130.9</c:v>
+                </c:pt>
+                <c:pt idx="5">
+                  <c:v>157.1</c:v>
+                </c:pt>
+              </c:numCache>
+            </c:numRef>
+          </c:val>
+          <c:smooth val="0"/>
+        </c:ser>
+        <c:ser>
+          <c:idx val="1"/>
+          <c:order val="1"/>
+          <c:tx>
+            <c:strRef>
+              <c:f>Sheet1!$C$1</c:f>
+              <c:strCache>
+                <c:ptCount val="1"/>
+                <c:pt idx="0">
+                  <c:v>Wide aisles · 2 carts</c:v>
+                </c:pt>
+              </c:strCache>
+            </c:strRef>
+          </c:tx>
+          <c:spPr>
+            <a:ln w="28575">
+              <a:solidFill>
+                <a:srgbClr val="2340B8"/>
+              </a:solidFill>
+            </a:ln>
+          </c:spPr>
+          <c:marker>
+            <c:symbol val="circle"/>
+            <c:size val="6"/>
+            <c:spPr>
+              <a:solidFill>
+                <a:srgbClr val="2340B8"/>
+              </a:solidFill>
+              <a:ln>
+                <a:solidFill>
+                  <a:srgbClr val="2340B8"/>
+                </a:solidFill>
+              </a:ln>
+            </c:spPr>
+          </c:marker>
+          <c:cat>
+            <c:strRef>
+              <c:f>Sheet1!$A$2:$A$7</c:f>
+              <c:strCache>
+                <c:ptCount val="6"/>
+                <c:pt idx="0">
+                  <c:v>1</c:v>
+                </c:pt>
+                <c:pt idx="1">
+                  <c:v>2</c:v>
+                </c:pt>
+                <c:pt idx="2">
+                  <c:v>3</c:v>
+                </c:pt>
+                <c:pt idx="3">
+                  <c:v>4</c:v>
+                </c:pt>
+                <c:pt idx="4">
+                  <c:v>5</c:v>
+                </c:pt>
+                <c:pt idx="5">
+                  <c:v>6</c:v>
+                </c:pt>
+              </c:strCache>
+            </c:strRef>
+          </c:cat>
+          <c:val>
+            <c:numRef>
+              <c:f>Sheet1!$C$2:$C$7</c:f>
+              <c:numCache>
+                <c:formatCode>General</c:formatCode>
+                <c:ptCount val="6"/>
+                <c:pt idx="0">
+                  <c:v>26.2</c:v>
+                </c:pt>
+                <c:pt idx="1">
+                  <c:v>52.4</c:v>
+                </c:pt>
+                <c:pt idx="2">
+                  <c:v>77.8</c:v>
+                </c:pt>
+                <c:pt idx="3">
+                  <c:v>102.3</c:v>
+                </c:pt>
+                <c:pt idx="4">
+                  <c:v>125.3</c:v>
+                </c:pt>
+                <c:pt idx="5">
+                  <c:v>146.0</c:v>
+                </c:pt>
+              </c:numCache>
+            </c:numRef>
+          </c:val>
+          <c:smooth val="0"/>
+        </c:ser>
+        <c:ser>
+          <c:idx val="2"/>
+          <c:order val="2"/>
+          <c:tx>
+            <c:strRef>
+              <c:f>Sheet1!$D$1</c:f>
+              <c:strCache>
+                <c:ptCount val="1"/>
+                <c:pt idx="0">
+                  <c:v>Narrow aisles · 1 cart</c:v>
+                </c:pt>
+              </c:strCache>
+            </c:strRef>
+          </c:tx>
+          <c:spPr>
+            <a:ln w="38100">
+              <a:solidFill>
+                <a:srgbClr val="E0442A"/>
+              </a:solidFill>
+            </a:ln>
+          </c:spPr>
+          <c:marker>
+            <c:symbol val="circle"/>
+            <c:size val="6"/>
+            <c:spPr>
+              <a:solidFill>
+                <a:srgbClr val="E0442A"/>
+              </a:solidFill>
+              <a:ln>
+                <a:solidFill>
+                  <a:srgbClr val="E0442A"/>
+                </a:solidFill>
+              </a:ln>
+            </c:spPr>
+          </c:marker>
+          <c:cat>
+            <c:strRef>
+              <c:f>Sheet1!$A$2:$A$7</c:f>
+              <c:strCache>
+                <c:ptCount val="6"/>
+                <c:pt idx="0">
+                  <c:v>1</c:v>
+                </c:pt>
+                <c:pt idx="1">
+                  <c:v>2</c:v>
+                </c:pt>
+                <c:pt idx="2">
+                  <c:v>3</c:v>
+                </c:pt>
+                <c:pt idx="3">
+                  <c:v>4</c:v>
+                </c:pt>
+                <c:pt idx="4">
+                  <c:v>5</c:v>
+                </c:pt>
+                <c:pt idx="5">
+                  <c:v>6</c:v>
+                </c:pt>
+              </c:strCache>
+            </c:strRef>
+          </c:cat>
+          <c:val>
+            <c:numRef>
+              <c:f>Sheet1!$D$2:$D$7</c:f>
+              <c:numCache>
+                <c:formatCode>General</c:formatCode>
+                <c:ptCount val="6"/>
+                <c:pt idx="0">
+                  <c:v>26.2</c:v>
+                </c:pt>
+                <c:pt idx="1">
+                  <c:v>48.0</c:v>
+                </c:pt>
+                <c:pt idx="2">
+                  <c:v>66.2</c:v>
+                </c:pt>
+                <c:pt idx="3">
+                  <c:v>80.8</c:v>
+                </c:pt>
+                <c:pt idx="4">
+                  <c:v>92.8</c:v>
+                </c:pt>
+                <c:pt idx="5">
+                  <c:v>101.4</c:v>
+                </c:pt>
+              </c:numCache>
+            </c:numRef>
+          </c:val>
+          <c:smooth val="0"/>
+        </c:ser>
+        <c:marker val="1"/>
+        <c:smooth val="0"/>
+        <c:axId val="2118791784"/>
+        <c:axId val="2140495176"/>
+      </c:lineChart>
+      <c:catAx>
+        <c:axId val="2118791784"/>
+        <c:scaling>
+          <c:orientation val="minMax"/>
+        </c:scaling>
+        <c:delete val="0"/>
+        <c:axPos val="b"/>
+        <c:title>
+          <c:tx>
+            <c:rich>
+              <a:bodyPr/>
+              <a:lstStyle/>
+              <a:p>
+                <a:r>
+                  <a:rPr sz="950" b="0">
+                    <a:solidFill>
+                      <a:srgbClr val="7D786C"/>
+                    </a:solidFill>
+                    <a:latin typeface="Bahnschrift"/>
+                  </a:rPr>
+                  <a:t>pickers on the floor</a:t>
+                </a:r>
+              </a:p>
+            </c:rich>
+          </c:tx>
+          <c:layout/>
+          <c:overlay val="0"/>
+        </c:title>
+        <c:majorTickMark val="out"/>
+        <c:minorTickMark val="none"/>
+        <c:tickLblPos val="nextTo"/>
+        <c:spPr>
+          <a:ln>
+            <a:solidFill>
+              <a:srgbClr val="1F2226"/>
+            </a:solidFill>
+          </a:ln>
+        </c:spPr>
+        <c:crossAx val="2140495176"/>
+        <c:crosses val="autoZero"/>
+        <c:auto val="1"/>
+        <c:lblAlgn val="ctr"/>
+        <c:lblOffset val="100"/>
+        <c:noMultiLvlLbl val="0"/>
+      </c:catAx>
+      <c:valAx>
+        <c:axId val="2140495176"/>
+        <c:scaling/>
+        <c:delete val="0"/>
+        <c:axPos val="l"/>
+        <c:majorGridlines>
+          <c:spPr>
+            <a:ln>
+              <a:solidFill>
+                <a:srgbClr val="D3CAB8"/>
+              </a:solidFill>
+            </a:ln>
+          </c:spPr>
+        </c:majorGridlines>
+        <c:title>
+          <c:tx>
+            <c:rich>
+              <a:bodyPr/>
+              <a:lstStyle/>
+              <a:p>
+                <a:r>
+                  <a:rPr sz="950" b="0">
+                    <a:solidFill>
+                      <a:srgbClr val="7D786C"/>
+                    </a:solidFill>
+                    <a:latin typeface="Bahnschrift"/>
+                  </a:rPr>
+                  <a:t>orders per hour</a:t>
+                </a:r>
+              </a:p>
+            </c:rich>
+          </c:tx>
+          <c:layout/>
+          <c:overlay val="0"/>
+        </c:title>
+        <c:majorTickMark val="out"/>
+        <c:minorTickMark val="none"/>
+        <c:tickLblPos val="nextTo"/>
+        <c:spPr>
+          <a:ln>
+            <a:noFill/>
+          </a:ln>
+        </c:spPr>
+        <c:crossAx val="2118791784"/>
+        <c:crosses val="autoZero"/>
+      </c:valAx>
+    </c:plotArea>
+    <c:legend>
+      <c:legendPos val="t"/>
+      <c:layout/>
+      <c:overlay val="0"/>
+    </c:legend>
+    <c:plotVisOnly val="1"/>
+    <c:dispBlanksAs val="gap"/>
+    <c:showDLblsOverMax val="0"/>
+  </c:chart>
+  <c:txPr>
+    <a:bodyPr/>
+    <a:lstStyle/>
+    <a:p>
+      <a:pPr>
+        <a:defRPr sz="1000">
+          <a:solidFill>
+            <a:srgbClr val="4A4D52"/>
+          </a:solidFill>
+          <a:latin typeface="Bahnschrift"/>
+        </a:defRPr>
+      </a:pPr>
+      <a:endParaRPr lang="en-US"/>
+    </a:p>
+  </c:txPr>
+  <c:externalData r:id="rId1">
+    <c:autoUpdate val="0"/>
+  </c:externalData>
+</c:chartSpace>
 </file>
 
 <file path=ppt/notesMasters/notesMaster1.xml><?xml version="1.0" encoding="utf-8"?>
@@ -582,7 +990,7 @@
           <a:lstStyle/>
           <a:p>
             <a:r>
-              <a:t>Demo. Click one rack, then another, to swap; the whole month re-scores instantly. Diamonds show products bought together. The live optimizer runs the same annealing in a background thread on your layout; in this screenshot it beat the offline optimizer, 182.3 km. Space to replay, 1 to 5 layouts, H heatmap, B batching, I IoT mode, O optimizer.</a:t>
+              <a:t>Real floors have more than one picker. We simulate a team of 1 to 6 pickers clearing the month's backlog. In a narrow aisle only one cart fits, so the next picker waits at the entrance. With 4 pickers the team loses about 23% of its capacity to queueing; with 6, about 35%. Wide aisles almost remove it. And the optimized layout's lead shrinks from 9% to 5%, because concentrating picks also concentrates people. Aisle width and batching matter as much as slotting once you have a team.</a:t>
             </a:r>
           </a:p>
         </p:txBody>
@@ -652,7 +1060,77 @@
           <a:lstStyle/>
           <a:p>
             <a:r>
-              <a:t>ECE angle: a digital twin needs sensors. The replay already emits the events real devices would stream: an RFID gate at the dock, a UWB tag on the cart, pick-to-light modules on every slot, and barcode confirmations. It downloads as JSON Lines, so real hardware can replace the replay. Next: several pickers and aisle congestion. Thank you, questions welcome.</a:t>
+              <a:t>Demo. Click one rack, then another, to swap; the whole month re-scores instantly. Diamonds show products bought together. The live optimizer runs the same annealing in a background thread on your layout; in this screenshot it beat the offline optimizer, 182.3 km. Space to replay, 1 to 5 layouts, H heatmap, B batching, I IoT mode, O optimizer.</a:t>
+            </a:r>
+          </a:p>
+        </p:txBody>
+      </p:sp>
+      <p:sp>
+        <p:nvSpPr>
+          <p:cNvPr id="4" name="Slide Number Placeholder 3"/>
+          <p:cNvSpPr>
+            <a:spLocks noGrp="1"/>
+          </p:cNvSpPr>
+          <p:nvPr>
+            <p:ph type="sldNum" idx="5" sz="quarter"/>
+          </p:nvPr>
+        </p:nvSpPr>
+        <p:spPr/>
+      </p:sp>
+    </p:spTree>
+  </p:cSld>
+  <p:clrMapOvr>
+    <a:masterClrMapping/>
+  </p:clrMapOvr>
+</p:notes>
+</file>
+
+<file path=ppt/notesSlides/notesSlide12.xml><?xml version="1.0" encoding="utf-8"?>
+<p:notes xmlns:a="http://schemas.openxmlformats.org/drawingml/2006/main" xmlns:p="http://schemas.openxmlformats.org/presentationml/2006/main" xmlns:r="http://schemas.openxmlformats.org/officeDocument/2006/relationships">
+  <p:cSld>
+    <p:spTree>
+      <p:nvGrpSpPr>
+        <p:cNvPr id="1" name=""/>
+        <p:cNvGrpSpPr/>
+        <p:nvPr/>
+      </p:nvGrpSpPr>
+      <p:grpSpPr>
+        <a:xfrm>
+          <a:off x="0" y="0"/>
+          <a:ext cx="0" cy="0"/>
+          <a:chOff x="0" y="0"/>
+          <a:chExt cx="0" cy="0"/>
+        </a:xfrm>
+      </p:grpSpPr>
+      <p:sp>
+        <p:nvSpPr>
+          <p:cNvPr id="2" name="Slide Image Placeholder 1"/>
+          <p:cNvSpPr>
+            <a:spLocks noGrp="1"/>
+          </p:cNvSpPr>
+          <p:nvPr>
+            <p:ph type="sldImg" idx="2"/>
+          </p:nvPr>
+        </p:nvSpPr>
+        <p:spPr/>
+      </p:sp>
+      <p:sp>
+        <p:nvSpPr>
+          <p:cNvPr id="3" name="Notes Placeholder 2"/>
+          <p:cNvSpPr>
+            <a:spLocks noGrp="1"/>
+          </p:cNvSpPr>
+          <p:nvPr>
+            <p:ph type="body" idx="3" sz="quarter"/>
+          </p:nvPr>
+        </p:nvSpPr>
+        <p:spPr/>
+        <p:txBody>
+          <a:bodyPr/>
+          <a:lstStyle/>
+          <a:p>
+            <a:r>
+              <a:t>ECE angle: a digital twin needs sensors. The replay already emits the events real devices would stream: an RFID gate at the dock, a UWB tag on the cart, pick-to-light modules on every slot, and barcode confirmations. It downloads as JSON Lines, so real hardware can replace the replay. Next: live sensor input and dynamic re-slotting. Thank you, questions welcome.</a:t>
             </a:r>
           </a:p>
         </p:txBody>
@@ -4308,7 +4786,7 @@
                 </a:solidFill>
                 <a:latin typeface="Cascadia Mono"/>
               </a:rPr>
-              <a:t> / 11</a:t>
+              <a:t> / 12</a:t>
             </a:r>
           </a:p>
         </p:txBody>
@@ -4488,7 +4966,7 @@
         <p:spPr>
           <a:xfrm>
             <a:off x="548640" y="548640"/>
-            <a:ext cx="1008583" cy="45720"/>
+            <a:ext cx="924534" cy="45720"/>
           </a:xfrm>
           <a:prstGeom prst="rect">
             <a:avLst/>
@@ -5326,7 +5804,7 @@
                 </a:solidFill>
                 <a:latin typeface="Cascadia Mono"/>
               </a:rPr>
-              <a:t> / 11</a:t>
+              <a:t> / 12</a:t>
             </a:r>
           </a:p>
         </p:txBody>
@@ -5505,8 +5983,8 @@
         </p:nvSpPr>
         <p:spPr>
           <a:xfrm>
-            <a:off x="9625888" y="548640"/>
-            <a:ext cx="1008583" cy="45720"/>
+            <a:off x="8869451" y="548640"/>
+            <a:ext cx="924534" cy="45720"/>
           </a:xfrm>
           <a:prstGeom prst="rect">
             <a:avLst/>
@@ -5584,7 +6062,7 @@
                 </a:solidFill>
                 <a:latin typeface="Bahnschrift SemiCondensed"/>
               </a:rPr>
-              <a:t>PLAY IT</a:t>
+              <a:t>A TEAM OF PICKERS</a:t>
             </a:r>
           </a:p>
         </p:txBody>
@@ -5598,7 +6076,7 @@
         <p:spPr>
           <a:xfrm>
             <a:off x="548640" y="1261872"/>
-            <a:ext cx="4206240" cy="1280160"/>
+            <a:ext cx="4572000" cy="1280160"/>
           </a:xfrm>
           <a:prstGeom prst="rect">
             <a:avLst/>
@@ -5626,22 +6104,142 @@
                 </a:solidFill>
                 <a:latin typeface="Bahnschrift SemiBold"/>
               </a:rPr>
-              <a:t>Can you beat
-the optimizer?</a:t>
-            </a:r>
-          </a:p>
-        </p:txBody>
-      </p:sp>
-      <p:sp>
-        <p:nvSpPr>
-          <p:cNvPr id="11" name="Rectangle 10"/>
+              <a:t>More pickers,
+more queueing</a:t>
+            </a:r>
+          </a:p>
+        </p:txBody>
+      </p:sp>
+      <p:sp>
+        <p:nvSpPr>
+          <p:cNvPr id="11" name="!!body"/>
+          <p:cNvSpPr txBox="1"/>
+          <p:nvPr/>
+        </p:nvSpPr>
+        <p:spPr>
+          <a:xfrm>
+            <a:off x="548640" y="2514600"/>
+            <a:ext cx="4206240" cy="1280160"/>
+          </a:xfrm>
+          <a:prstGeom prst="rect">
+            <a:avLst/>
+          </a:prstGeom>
+          <a:noFill/>
+        </p:spPr>
+        <p:txBody>
+          <a:bodyPr wrap="square" lIns="0" rIns="0" tIns="0" bIns="0" anchor="t">
+            <a:spAutoFit/>
+          </a:bodyPr>
+          <a:lstStyle/>
+          <a:p>
+            <a:pPr algn="l">
+              <a:lnSpc>
+                <a:spcPct val="112000"/>
+              </a:lnSpc>
+              <a:spcAft>
+                <a:spcPts val="0"/>
+              </a:spcAft>
+            </a:pPr>
+            <a:r>
+              <a:rPr sz="1350" b="0">
+                <a:solidFill>
+                  <a:srgbClr val="4A4D52"/>
+                </a:solidFill>
+                <a:latin typeface="Bahnschrift"/>
+              </a:rPr>
+              <a:t>Up to six pickers clear the month's backlog together. A narrow aisle fits one cart, so the next picker waits at the entrance.</a:t>
+            </a:r>
+          </a:p>
+        </p:txBody>
+      </p:sp>
+      <p:sp>
+        <p:nvSpPr>
+          <p:cNvPr id="12" name="!!num"/>
+          <p:cNvSpPr txBox="1"/>
+          <p:nvPr/>
+        </p:nvSpPr>
+        <p:spPr>
+          <a:xfrm>
+            <a:off x="548640" y="3520440"/>
+            <a:ext cx="2743200" cy="822960"/>
+          </a:xfrm>
+          <a:prstGeom prst="rect">
+            <a:avLst/>
+          </a:prstGeom>
+          <a:noFill/>
+        </p:spPr>
+        <p:txBody>
+          <a:bodyPr wrap="square" lIns="0" rIns="0" tIns="0" bIns="0" anchor="t">
+            <a:spAutoFit/>
+          </a:bodyPr>
+          <a:lstStyle/>
+          <a:p>
+            <a:pPr algn="l">
+              <a:spcAft>
+                <a:spcPts val="0"/>
+              </a:spcAft>
+            </a:pPr>
+            <a:r>
+              <a:rPr sz="6000" b="0">
+                <a:solidFill>
+                  <a:srgbClr val="E0442A"/>
+                </a:solidFill>
+                <a:latin typeface="Bahnschrift Light"/>
+              </a:rPr>
+              <a:t>23%</a:t>
+            </a:r>
+          </a:p>
+        </p:txBody>
+      </p:sp>
+      <p:sp>
+        <p:nvSpPr>
+          <p:cNvPr id="13" name="!!sub"/>
+          <p:cNvSpPr txBox="1"/>
+          <p:nvPr/>
+        </p:nvSpPr>
+        <p:spPr>
+          <a:xfrm>
+            <a:off x="548640" y="4370832"/>
+            <a:ext cx="4206240" cy="274320"/>
+          </a:xfrm>
+          <a:prstGeom prst="rect">
+            <a:avLst/>
+          </a:prstGeom>
+          <a:noFill/>
+        </p:spPr>
+        <p:txBody>
+          <a:bodyPr wrap="square" lIns="0" rIns="0" tIns="0" bIns="0" anchor="t">
+            <a:spAutoFit/>
+          </a:bodyPr>
+          <a:lstStyle/>
+          <a:p>
+            <a:pPr algn="l">
+              <a:spcAft>
+                <a:spcPts val="0"/>
+              </a:spcAft>
+            </a:pPr>
+            <a:r>
+              <a:rPr sz="1050" b="0">
+                <a:solidFill>
+                  <a:srgbClr val="4A4D52"/>
+                </a:solidFill>
+                <a:latin typeface="Cascadia Mono"/>
+              </a:rPr>
+              <a:t>of a 4-picker team's capacity lost in narrow aisles</a:t>
+            </a:r>
+          </a:p>
+        </p:txBody>
+      </p:sp>
+      <p:sp>
+        <p:nvSpPr>
+          <p:cNvPr id="14" name="Rectangle 13"/>
           <p:cNvSpPr/>
           <p:nvPr/>
         </p:nvSpPr>
         <p:spPr>
           <a:xfrm>
-            <a:off x="4864608" y="978408"/>
-            <a:ext cx="6812280" cy="3831907"/>
+            <a:off x="548640" y="4846320"/>
+            <a:ext cx="4206240" cy="9525"/>
           </a:xfrm>
           <a:prstGeom prst="rect">
             <a:avLst/>
@@ -5676,45 +6274,234 @@
           </a:p>
         </p:txBody>
       </p:sp>
-      <p:pic>
-        <p:nvPicPr>
-          <p:cNvPr id="12" name="!!hero" descr="app_game.jpg"/>
-          <p:cNvPicPr>
-            <a:picLocks noChangeAspect="1"/>
-          </p:cNvPicPr>
-          <p:nvPr/>
-        </p:nvPicPr>
-        <p:blipFill>
-          <a:blip r:embed="rId3"/>
-          <a:stretch>
-            <a:fillRect/>
-          </a:stretch>
-        </p:blipFill>
-        <p:spPr>
-          <a:xfrm>
-            <a:off x="4800600" y="914400"/>
-            <a:ext cx="6812280" cy="3831908"/>
-          </a:xfrm>
-          <a:prstGeom prst="rect">
-            <a:avLst/>
-          </a:prstGeom>
-          <a:ln w="12700">
-            <a:solidFill>
-              <a:srgbClr val="1F2226"/>
-            </a:solidFill>
+      <p:sp>
+        <p:nvSpPr>
+          <p:cNvPr id="15" name="TextBox 14"/>
+          <p:cNvSpPr txBox="1"/>
+          <p:nvPr/>
+        </p:nvSpPr>
+        <p:spPr>
+          <a:xfrm>
+            <a:off x="548640" y="4919472"/>
+            <a:ext cx="4206240" cy="274320"/>
+          </a:xfrm>
+          <a:prstGeom prst="rect">
+            <a:avLst/>
+          </a:prstGeom>
+          <a:noFill/>
+        </p:spPr>
+        <p:txBody>
+          <a:bodyPr wrap="square" lIns="0" rIns="0" tIns="0" bIns="0" anchor="t">
+            <a:spAutoFit/>
+          </a:bodyPr>
+          <a:lstStyle/>
+          <a:p>
+            <a:pPr algn="l">
+              <a:spcAft>
+                <a:spcPts val="0"/>
+              </a:spcAft>
+            </a:pPr>
+            <a:r>
+              <a:rPr sz="1300" b="0">
+                <a:solidFill>
+                  <a:srgbClr val="1F2226"/>
+                </a:solidFill>
+                <a:latin typeface="Bahnschrift SemiBold"/>
+              </a:rPr>
+              <a:t>6 pickers</a:t>
+            </a:r>
+          </a:p>
+        </p:txBody>
+      </p:sp>
+      <p:sp>
+        <p:nvSpPr>
+          <p:cNvPr id="16" name="TextBox 15"/>
+          <p:cNvSpPr txBox="1"/>
+          <p:nvPr/>
+        </p:nvSpPr>
+        <p:spPr>
+          <a:xfrm>
+            <a:off x="548640" y="5175504"/>
+            <a:ext cx="4206240" cy="274320"/>
+          </a:xfrm>
+          <a:prstGeom prst="rect">
+            <a:avLst/>
+          </a:prstGeom>
+          <a:noFill/>
+        </p:spPr>
+        <p:txBody>
+          <a:bodyPr wrap="square" lIns="0" rIns="0" tIns="0" bIns="0" anchor="t">
+            <a:spAutoFit/>
+          </a:bodyPr>
+          <a:lstStyle/>
+          <a:p>
+            <a:pPr algn="l">
+              <a:spcAft>
+                <a:spcPts val="0"/>
+              </a:spcAft>
+            </a:pPr>
+            <a:r>
+              <a:rPr sz="1050" b="0">
+                <a:solidFill>
+                  <a:srgbClr val="4A4D52"/>
+                </a:solidFill>
+                <a:latin typeface="Bahnschrift"/>
+              </a:rPr>
+              <a:t>35% lost; month in 22.6 h vs 15.7 h with wide aisles</a:t>
+            </a:r>
+          </a:p>
+        </p:txBody>
+      </p:sp>
+      <p:sp>
+        <p:nvSpPr>
+          <p:cNvPr id="17" name="Rectangle 16"/>
+          <p:cNvSpPr/>
+          <p:nvPr/>
+        </p:nvSpPr>
+        <p:spPr>
+          <a:xfrm>
+            <a:off x="548640" y="5413248"/>
+            <a:ext cx="4206240" cy="9525"/>
+          </a:xfrm>
+          <a:prstGeom prst="rect">
+            <a:avLst/>
+          </a:prstGeom>
+          <a:solidFill>
+            <a:srgbClr val="D3CAB8"/>
+          </a:solidFill>
+          <a:ln>
+            <a:noFill/>
           </a:ln>
-        </p:spPr>
-      </p:pic>
-      <p:sp>
-        <p:nvSpPr>
-          <p:cNvPr id="13" name="Rectangle 12"/>
+          <a:effectLst/>
+        </p:spPr>
+        <p:style>
+          <a:lnRef idx="1">
+            <a:schemeClr val="accent1"/>
+          </a:lnRef>
+          <a:fillRef idx="3">
+            <a:schemeClr val="accent1"/>
+          </a:fillRef>
+          <a:effectRef idx="2">
+            <a:schemeClr val="accent1"/>
+          </a:effectRef>
+          <a:fontRef idx="minor">
+            <a:schemeClr val="lt1"/>
+          </a:fontRef>
+        </p:style>
+        <p:txBody>
+          <a:bodyPr rtlCol="0" anchor="ctr"/>
+          <a:lstStyle/>
+          <a:p>
+            <a:pPr algn="ctr"/>
+          </a:p>
+        </p:txBody>
+      </p:sp>
+      <p:sp>
+        <p:nvSpPr>
+          <p:cNvPr id="18" name="TextBox 17"/>
+          <p:cNvSpPr txBox="1"/>
+          <p:nvPr/>
+        </p:nvSpPr>
+        <p:spPr>
+          <a:xfrm>
+            <a:off x="548640" y="5486400"/>
+            <a:ext cx="4206240" cy="274320"/>
+          </a:xfrm>
+          <a:prstGeom prst="rect">
+            <a:avLst/>
+          </a:prstGeom>
+          <a:noFill/>
+        </p:spPr>
+        <p:txBody>
+          <a:bodyPr wrap="square" lIns="0" rIns="0" tIns="0" bIns="0" anchor="t">
+            <a:spAutoFit/>
+          </a:bodyPr>
+          <a:lstStyle/>
+          <a:p>
+            <a:pPr algn="l">
+              <a:spcAft>
+                <a:spcPts val="0"/>
+              </a:spcAft>
+            </a:pPr>
+            <a:r>
+              <a:rPr sz="1300" b="0">
+                <a:solidFill>
+                  <a:srgbClr val="1F2226"/>
+                </a:solidFill>
+                <a:latin typeface="Bahnschrift SemiBold"/>
+              </a:rPr>
+              <a:t>Slotting vs people</a:t>
+            </a:r>
+          </a:p>
+        </p:txBody>
+      </p:sp>
+      <p:sp>
+        <p:nvSpPr>
+          <p:cNvPr id="19" name="TextBox 18"/>
+          <p:cNvSpPr txBox="1"/>
+          <p:nvPr/>
+        </p:nvSpPr>
+        <p:spPr>
+          <a:xfrm>
+            <a:off x="548640" y="5742432"/>
+            <a:ext cx="4206240" cy="274320"/>
+          </a:xfrm>
+          <a:prstGeom prst="rect">
+            <a:avLst/>
+          </a:prstGeom>
+          <a:noFill/>
+        </p:spPr>
+        <p:txBody>
+          <a:bodyPr wrap="square" lIns="0" rIns="0" tIns="0" bIns="0" anchor="t">
+            <a:spAutoFit/>
+          </a:bodyPr>
+          <a:lstStyle/>
+          <a:p>
+            <a:pPr algn="l">
+              <a:spcAft>
+                <a:spcPts val="0"/>
+              </a:spcAft>
+            </a:pPr>
+            <a:r>
+              <a:rPr sz="1050" b="0">
+                <a:solidFill>
+                  <a:srgbClr val="4A4D52"/>
+                </a:solidFill>
+                <a:latin typeface="Bahnschrift"/>
+              </a:rPr>
+              <a:t>Optimized leads by +9% with 1 picker, +5% with 6</a:t>
+            </a:r>
+          </a:p>
+        </p:txBody>
+      </p:sp>
+      <p:graphicFrame>
+        <p:nvGraphicFramePr>
+          <p:cNvPr id="20" name="!!chart"/>
+          <p:cNvGraphicFramePr>
+            <a:graphicFrameLocks noGrp="1"/>
+          </p:cNvGraphicFramePr>
+          <p:nvPr/>
+        </p:nvGraphicFramePr>
+        <p:xfrm>
+          <a:off x="5120640" y="914400"/>
+          <a:ext cx="3886200" cy="5074920"/>
+        </p:xfrm>
+        <a:graphic>
+          <a:graphicData uri="http://schemas.openxmlformats.org/drawingml/2006/chart">
+            <c:chart xmlns:c="http://schemas.openxmlformats.org/drawingml/2006/chart" r:id="rId3"/>
+          </a:graphicData>
+        </a:graphic>
+      </p:graphicFrame>
+      <p:sp>
+        <p:nvSpPr>
+          <p:cNvPr id="21" name="Rectangle 20"/>
           <p:cNvSpPr/>
           <p:nvPr/>
         </p:nvSpPr>
         <p:spPr>
           <a:xfrm>
-            <a:off x="548640" y="2514600"/>
-            <a:ext cx="3931920" cy="9525"/>
+            <a:off x="9299448" y="1252728"/>
+            <a:ext cx="2395728" cy="1347597"/>
           </a:xfrm>
           <a:prstGeom prst="rect">
             <a:avLst/>
@@ -5749,94 +6536,45 @@
           </a:p>
         </p:txBody>
       </p:sp>
-      <p:sp>
-        <p:nvSpPr>
-          <p:cNvPr id="14" name="TextBox 13"/>
-          <p:cNvSpPr txBox="1"/>
-          <p:nvPr/>
-        </p:nvSpPr>
-        <p:spPr>
-          <a:xfrm>
-            <a:off x="548640" y="2606040"/>
-            <a:ext cx="457200" cy="274320"/>
-          </a:xfrm>
-          <a:prstGeom prst="rect">
-            <a:avLst/>
-          </a:prstGeom>
-          <a:noFill/>
-        </p:spPr>
-        <p:txBody>
-          <a:bodyPr wrap="square" lIns="0" rIns="0" tIns="0" bIns="0" anchor="t">
-            <a:spAutoFit/>
-          </a:bodyPr>
-          <a:lstStyle/>
-          <a:p>
-            <a:pPr algn="l">
-              <a:spcAft>
-                <a:spcPts val="0"/>
-              </a:spcAft>
-            </a:pPr>
-            <a:r>
-              <a:rPr sz="1000" b="0">
-                <a:solidFill>
-                  <a:srgbClr val="E0442A"/>
-                </a:solidFill>
-                <a:latin typeface="Cascadia Mono"/>
-              </a:rPr>
-              <a:t>01</a:t>
-            </a:r>
-          </a:p>
-        </p:txBody>
-      </p:sp>
-      <p:sp>
-        <p:nvSpPr>
-          <p:cNvPr id="15" name="TextBox 14"/>
-          <p:cNvSpPr txBox="1"/>
-          <p:nvPr/>
-        </p:nvSpPr>
-        <p:spPr>
-          <a:xfrm>
-            <a:off x="1005840" y="2578608"/>
-            <a:ext cx="3474720" cy="274320"/>
-          </a:xfrm>
-          <a:prstGeom prst="rect">
-            <a:avLst/>
-          </a:prstGeom>
-          <a:noFill/>
-        </p:spPr>
-        <p:txBody>
-          <a:bodyPr wrap="square" lIns="0" rIns="0" tIns="0" bIns="0" anchor="t">
-            <a:spAutoFit/>
-          </a:bodyPr>
-          <a:lstStyle/>
-          <a:p>
-            <a:pPr algn="l">
-              <a:spcAft>
-                <a:spcPts val="0"/>
-              </a:spcAft>
-            </a:pPr>
-            <a:r>
-              <a:rPr sz="1400" b="0">
-                <a:solidFill>
-                  <a:srgbClr val="1F2226"/>
-                </a:solidFill>
-                <a:latin typeface="Bahnschrift SemiBold"/>
-              </a:rPr>
-              <a:t>Swap racks</a:t>
-            </a:r>
-          </a:p>
-        </p:txBody>
-      </p:sp>
-      <p:sp>
-        <p:nvSpPr>
-          <p:cNvPr id="16" name="TextBox 15"/>
-          <p:cNvSpPr txBox="1"/>
-          <p:nvPr/>
-        </p:nvSpPr>
-        <p:spPr>
-          <a:xfrm>
-            <a:off x="1005840" y="2880360"/>
-            <a:ext cx="3474720" cy="411480"/>
+      <p:pic>
+        <p:nvPicPr>
+          <p:cNvPr id="22" name="Picture 21" descr="app_team.jpg"/>
+          <p:cNvPicPr>
+            <a:picLocks noChangeAspect="1"/>
+          </p:cNvPicPr>
+          <p:nvPr/>
+        </p:nvPicPr>
+        <p:blipFill>
+          <a:blip r:embed="rId4"/>
+          <a:stretch>
+            <a:fillRect/>
+          </a:stretch>
+        </p:blipFill>
+        <p:spPr>
+          <a:xfrm>
+            <a:off x="9235440" y="1188720"/>
+            <a:ext cx="2395728" cy="1347597"/>
+          </a:xfrm>
+          <a:prstGeom prst="rect">
+            <a:avLst/>
+          </a:prstGeom>
+          <a:ln w="12700">
+            <a:solidFill>
+              <a:srgbClr val="1F2226"/>
+            </a:solidFill>
+          </a:ln>
+        </p:spPr>
+      </p:pic>
+      <p:sp>
+        <p:nvSpPr>
+          <p:cNvPr id="23" name="TextBox 22"/>
+          <p:cNvSpPr txBox="1"/>
+          <p:nvPr/>
+        </p:nvSpPr>
+        <p:spPr>
+          <a:xfrm>
+            <a:off x="9235440" y="2606040"/>
+            <a:ext cx="2395728" cy="1097280"/>
           </a:xfrm>
           <a:prstGeom prst="rect">
             <a:avLst/>
@@ -5851,156 +6589,34 @@
           <a:p>
             <a:pPr algn="l">
               <a:lnSpc>
-                <a:spcPct val="105000"/>
+                <a:spcPct val="110000"/>
               </a:lnSpc>
               <a:spcAft>
                 <a:spcPts val="0"/>
               </a:spcAft>
             </a:pPr>
             <a:r>
-              <a:rPr sz="1050" b="0">
+              <a:rPr sz="950" b="0">
                 <a:solidFill>
                   <a:srgbClr val="4A4D52"/>
                 </a:solidFill>
                 <a:latin typeface="Bahnschrift"/>
               </a:rPr>
-              <a:t>The month re-scores instantly; ◆ marks what is bought together.</a:t>
-            </a:r>
-          </a:p>
-        </p:txBody>
-      </p:sp>
-      <p:sp>
-        <p:nvSpPr>
-          <p:cNvPr id="17" name="Rectangle 16"/>
-          <p:cNvSpPr/>
-          <p:nvPr/>
-        </p:nvSpPr>
-        <p:spPr>
-          <a:xfrm>
-            <a:off x="548640" y="3300984"/>
-            <a:ext cx="3931920" cy="9525"/>
-          </a:xfrm>
-          <a:prstGeom prst="rect">
-            <a:avLst/>
-          </a:prstGeom>
-          <a:solidFill>
-            <a:srgbClr val="D3CAB8"/>
-          </a:solidFill>
-          <a:ln>
-            <a:noFill/>
-          </a:ln>
-          <a:effectLst/>
-        </p:spPr>
-        <p:style>
-          <a:lnRef idx="1">
-            <a:schemeClr val="accent1"/>
-          </a:lnRef>
-          <a:fillRef idx="3">
-            <a:schemeClr val="accent1"/>
-          </a:fillRef>
-          <a:effectRef idx="2">
-            <a:schemeClr val="accent1"/>
-          </a:effectRef>
-          <a:fontRef idx="minor">
-            <a:schemeClr val="lt1"/>
-          </a:fontRef>
-        </p:style>
-        <p:txBody>
-          <a:bodyPr rtlCol="0" anchor="ctr"/>
-          <a:lstStyle/>
-          <a:p>
-            <a:pPr algn="ctr"/>
-          </a:p>
-        </p:txBody>
-      </p:sp>
-      <p:sp>
-        <p:nvSpPr>
-          <p:cNvPr id="18" name="TextBox 17"/>
-          <p:cNvSpPr txBox="1"/>
-          <p:nvPr/>
-        </p:nvSpPr>
-        <p:spPr>
-          <a:xfrm>
-            <a:off x="548640" y="3392424"/>
-            <a:ext cx="457200" cy="274320"/>
-          </a:xfrm>
-          <a:prstGeom prst="rect">
-            <a:avLst/>
-          </a:prstGeom>
-          <a:noFill/>
-        </p:spPr>
-        <p:txBody>
-          <a:bodyPr wrap="square" lIns="0" rIns="0" tIns="0" bIns="0" anchor="t">
-            <a:spAutoFit/>
-          </a:bodyPr>
-          <a:lstStyle/>
-          <a:p>
-            <a:pPr algn="l">
-              <a:spcAft>
-                <a:spcPts val="0"/>
-              </a:spcAft>
-            </a:pPr>
-            <a:r>
-              <a:rPr sz="1000" b="0">
-                <a:solidFill>
-                  <a:srgbClr val="E0442A"/>
-                </a:solidFill>
-                <a:latin typeface="Cascadia Mono"/>
-              </a:rPr>
-              <a:t>02</a:t>
-            </a:r>
-          </a:p>
-        </p:txBody>
-      </p:sp>
-      <p:sp>
-        <p:nvSpPr>
-          <p:cNvPr id="19" name="TextBox 18"/>
-          <p:cNvSpPr txBox="1"/>
-          <p:nvPr/>
-        </p:nvSpPr>
-        <p:spPr>
-          <a:xfrm>
-            <a:off x="1005840" y="3364991"/>
-            <a:ext cx="3474720" cy="274320"/>
-          </a:xfrm>
-          <a:prstGeom prst="rect">
-            <a:avLst/>
-          </a:prstGeom>
-          <a:noFill/>
-        </p:spPr>
-        <p:txBody>
-          <a:bodyPr wrap="square" lIns="0" rIns="0" tIns="0" bIns="0" anchor="t">
-            <a:spAutoFit/>
-          </a:bodyPr>
-          <a:lstStyle/>
-          <a:p>
-            <a:pPr algn="l">
-              <a:spcAft>
-                <a:spcPts val="0"/>
-              </a:spcAft>
-            </a:pPr>
-            <a:r>
-              <a:rPr sz="1400" b="0">
-                <a:solidFill>
-                  <a:srgbClr val="1F2226"/>
-                </a:solidFill>
-                <a:latin typeface="Bahnschrift SemiBold"/>
-              </a:rPr>
-              <a:t>Live optimizer</a:t>
-            </a:r>
-          </a:p>
-        </p:txBody>
-      </p:sp>
-      <p:sp>
-        <p:nvSpPr>
-          <p:cNvPr id="20" name="TextBox 19"/>
-          <p:cNvSpPr txBox="1"/>
-          <p:nvPr/>
-        </p:nvSpPr>
-        <p:spPr>
-          <a:xfrm>
-            <a:off x="1005840" y="3666744"/>
-            <a:ext cx="3474720" cy="411480"/>
+              <a:t>In the app: numbered pickers, a pulsing ring while queued, live waiting share and aisle-blocked IoT events.</a:t>
+            </a:r>
+          </a:p>
+        </p:txBody>
+      </p:sp>
+      <p:sp>
+        <p:nvSpPr>
+          <p:cNvPr id="24" name="TextBox 23"/>
+          <p:cNvSpPr txBox="1"/>
+          <p:nvPr/>
+        </p:nvSpPr>
+        <p:spPr>
+          <a:xfrm>
+            <a:off x="9235440" y="3840480"/>
+            <a:ext cx="2395728" cy="1463040"/>
           </a:xfrm>
           <a:prstGeom prst="rect">
             <a:avLst/>
@@ -6015,387 +6631,29 @@
           <a:p>
             <a:pPr algn="l">
               <a:lnSpc>
-                <a:spcPct val="105000"/>
+                <a:spcPct val="110000"/>
               </a:lnSpc>
               <a:spcAft>
                 <a:spcPts val="0"/>
               </a:spcAft>
             </a:pPr>
             <a:r>
-              <a:rPr sz="1050" b="0">
+              <a:rPr sz="950" b="0">
+                <a:solidFill>
+                  <a:srgbClr val="1F2226"/>
+                </a:solidFill>
+                <a:latin typeface="Bahnschrift SemiBold"/>
+              </a:rPr>
+              <a:t>Backlog model. </a:t>
+            </a:r>
+            <a:r>
+              <a:rPr sz="950" b="0">
                 <a:solidFill>
                   <a:srgbClr val="4A4D52"/>
                 </a:solidFill>
                 <a:latin typeface="Bahnschrift"/>
               </a:rPr>
-              <a:t>Annealing in a Web Worker on your layout. Here: 182.3 km in 14 s.</a:t>
-            </a:r>
-          </a:p>
-        </p:txBody>
-      </p:sp>
-      <p:sp>
-        <p:nvSpPr>
-          <p:cNvPr id="21" name="Rectangle 20"/>
-          <p:cNvSpPr/>
-          <p:nvPr/>
-        </p:nvSpPr>
-        <p:spPr>
-          <a:xfrm>
-            <a:off x="548640" y="4087368"/>
-            <a:ext cx="3931920" cy="9525"/>
-          </a:xfrm>
-          <a:prstGeom prst="rect">
-            <a:avLst/>
-          </a:prstGeom>
-          <a:solidFill>
-            <a:srgbClr val="D3CAB8"/>
-          </a:solidFill>
-          <a:ln>
-            <a:noFill/>
-          </a:ln>
-          <a:effectLst/>
-        </p:spPr>
-        <p:style>
-          <a:lnRef idx="1">
-            <a:schemeClr val="accent1"/>
-          </a:lnRef>
-          <a:fillRef idx="3">
-            <a:schemeClr val="accent1"/>
-          </a:fillRef>
-          <a:effectRef idx="2">
-            <a:schemeClr val="accent1"/>
-          </a:effectRef>
-          <a:fontRef idx="minor">
-            <a:schemeClr val="lt1"/>
-          </a:fontRef>
-        </p:style>
-        <p:txBody>
-          <a:bodyPr rtlCol="0" anchor="ctr"/>
-          <a:lstStyle/>
-          <a:p>
-            <a:pPr algn="ctr"/>
-          </a:p>
-        </p:txBody>
-      </p:sp>
-      <p:sp>
-        <p:nvSpPr>
-          <p:cNvPr id="22" name="TextBox 21"/>
-          <p:cNvSpPr txBox="1"/>
-          <p:nvPr/>
-        </p:nvSpPr>
-        <p:spPr>
-          <a:xfrm>
-            <a:off x="548640" y="4178807"/>
-            <a:ext cx="457200" cy="274320"/>
-          </a:xfrm>
-          <a:prstGeom prst="rect">
-            <a:avLst/>
-          </a:prstGeom>
-          <a:noFill/>
-        </p:spPr>
-        <p:txBody>
-          <a:bodyPr wrap="square" lIns="0" rIns="0" tIns="0" bIns="0" anchor="t">
-            <a:spAutoFit/>
-          </a:bodyPr>
-          <a:lstStyle/>
-          <a:p>
-            <a:pPr algn="l">
-              <a:spcAft>
-                <a:spcPts val="0"/>
-              </a:spcAft>
-            </a:pPr>
-            <a:r>
-              <a:rPr sz="1000" b="0">
-                <a:solidFill>
-                  <a:srgbClr val="E0442A"/>
-                </a:solidFill>
-                <a:latin typeface="Cascadia Mono"/>
-              </a:rPr>
-              <a:t>03</a:t>
-            </a:r>
-          </a:p>
-        </p:txBody>
-      </p:sp>
-      <p:sp>
-        <p:nvSpPr>
-          <p:cNvPr id="23" name="TextBox 22"/>
-          <p:cNvSpPr txBox="1"/>
-          <p:nvPr/>
-        </p:nvSpPr>
-        <p:spPr>
-          <a:xfrm>
-            <a:off x="1005840" y="4151376"/>
-            <a:ext cx="3474720" cy="274320"/>
-          </a:xfrm>
-          <a:prstGeom prst="rect">
-            <a:avLst/>
-          </a:prstGeom>
-          <a:noFill/>
-        </p:spPr>
-        <p:txBody>
-          <a:bodyPr wrap="square" lIns="0" rIns="0" tIns="0" bIns="0" anchor="t">
-            <a:spAutoFit/>
-          </a:bodyPr>
-          <a:lstStyle/>
-          <a:p>
-            <a:pPr algn="l">
-              <a:spcAft>
-                <a:spcPts val="0"/>
-              </a:spcAft>
-            </a:pPr>
-            <a:r>
-              <a:rPr sz="1400" b="0">
-                <a:solidFill>
-                  <a:srgbClr val="1F2226"/>
-                </a:solidFill>
-                <a:latin typeface="Bahnschrift SemiBold"/>
-              </a:rPr>
-              <a:t>See the traffic</a:t>
-            </a:r>
-          </a:p>
-        </p:txBody>
-      </p:sp>
-      <p:sp>
-        <p:nvSpPr>
-          <p:cNvPr id="24" name="TextBox 23"/>
-          <p:cNvSpPr txBox="1"/>
-          <p:nvPr/>
-        </p:nvSpPr>
-        <p:spPr>
-          <a:xfrm>
-            <a:off x="1005840" y="4453128"/>
-            <a:ext cx="3474720" cy="411480"/>
-          </a:xfrm>
-          <a:prstGeom prst="rect">
-            <a:avLst/>
-          </a:prstGeom>
-          <a:noFill/>
-        </p:spPr>
-        <p:txBody>
-          <a:bodyPr wrap="square" lIns="0" rIns="0" tIns="0" bIns="0" anchor="t">
-            <a:spAutoFit/>
-          </a:bodyPr>
-          <a:lstStyle/>
-          <a:p>
-            <a:pPr algn="l">
-              <a:lnSpc>
-                <a:spcPct val="105000"/>
-              </a:lnSpc>
-              <a:spcAft>
-                <a:spcPts val="0"/>
-              </a:spcAft>
-            </a:pPr>
-            <a:r>
-              <a:rPr sz="1050" b="0">
-                <a:solidFill>
-                  <a:srgbClr val="4A4D52"/>
-                </a:solidFill>
-                <a:latin typeface="Bahnschrift"/>
-              </a:rPr>
-              <a:t>Rack visit colours and a floor heatmap of walking passes.</a:t>
-            </a:r>
-          </a:p>
-        </p:txBody>
-      </p:sp>
-      <p:sp>
-        <p:nvSpPr>
-          <p:cNvPr id="25" name="Rectangle 24"/>
-          <p:cNvSpPr/>
-          <p:nvPr/>
-        </p:nvSpPr>
-        <p:spPr>
-          <a:xfrm>
-            <a:off x="548640" y="4873752"/>
-            <a:ext cx="3931920" cy="9525"/>
-          </a:xfrm>
-          <a:prstGeom prst="rect">
-            <a:avLst/>
-          </a:prstGeom>
-          <a:solidFill>
-            <a:srgbClr val="D3CAB8"/>
-          </a:solidFill>
-          <a:ln>
-            <a:noFill/>
-          </a:ln>
-          <a:effectLst/>
-        </p:spPr>
-        <p:style>
-          <a:lnRef idx="1">
-            <a:schemeClr val="accent1"/>
-          </a:lnRef>
-          <a:fillRef idx="3">
-            <a:schemeClr val="accent1"/>
-          </a:fillRef>
-          <a:effectRef idx="2">
-            <a:schemeClr val="accent1"/>
-          </a:effectRef>
-          <a:fontRef idx="minor">
-            <a:schemeClr val="lt1"/>
-          </a:fontRef>
-        </p:style>
-        <p:txBody>
-          <a:bodyPr rtlCol="0" anchor="ctr"/>
-          <a:lstStyle/>
-          <a:p>
-            <a:pPr algn="ctr"/>
-          </a:p>
-        </p:txBody>
-      </p:sp>
-      <p:sp>
-        <p:nvSpPr>
-          <p:cNvPr id="26" name="TextBox 25"/>
-          <p:cNvSpPr txBox="1"/>
-          <p:nvPr/>
-        </p:nvSpPr>
-        <p:spPr>
-          <a:xfrm>
-            <a:off x="548640" y="4965192"/>
-            <a:ext cx="457200" cy="274320"/>
-          </a:xfrm>
-          <a:prstGeom prst="rect">
-            <a:avLst/>
-          </a:prstGeom>
-          <a:noFill/>
-        </p:spPr>
-        <p:txBody>
-          <a:bodyPr wrap="square" lIns="0" rIns="0" tIns="0" bIns="0" anchor="t">
-            <a:spAutoFit/>
-          </a:bodyPr>
-          <a:lstStyle/>
-          <a:p>
-            <a:pPr algn="l">
-              <a:spcAft>
-                <a:spcPts val="0"/>
-              </a:spcAft>
-            </a:pPr>
-            <a:r>
-              <a:rPr sz="1000" b="0">
-                <a:solidFill>
-                  <a:srgbClr val="E0442A"/>
-                </a:solidFill>
-                <a:latin typeface="Cascadia Mono"/>
-              </a:rPr>
-              <a:t>04</a:t>
-            </a:r>
-          </a:p>
-        </p:txBody>
-      </p:sp>
-      <p:sp>
-        <p:nvSpPr>
-          <p:cNvPr id="27" name="TextBox 26"/>
-          <p:cNvSpPr txBox="1"/>
-          <p:nvPr/>
-        </p:nvSpPr>
-        <p:spPr>
-          <a:xfrm>
-            <a:off x="1005840" y="4937760"/>
-            <a:ext cx="3474720" cy="274320"/>
-          </a:xfrm>
-          <a:prstGeom prst="rect">
-            <a:avLst/>
-          </a:prstGeom>
-          <a:noFill/>
-        </p:spPr>
-        <p:txBody>
-          <a:bodyPr wrap="square" lIns="0" rIns="0" tIns="0" bIns="0" anchor="t">
-            <a:spAutoFit/>
-          </a:bodyPr>
-          <a:lstStyle/>
-          <a:p>
-            <a:pPr algn="l">
-              <a:spcAft>
-                <a:spcPts val="0"/>
-              </a:spcAft>
-            </a:pPr>
-            <a:r>
-              <a:rPr sz="1400" b="0">
-                <a:solidFill>
-                  <a:srgbClr val="1F2226"/>
-                </a:solidFill>
-                <a:latin typeface="Bahnschrift SemiBold"/>
-              </a:rPr>
-              <a:t>IoT sensor mode</a:t>
-            </a:r>
-          </a:p>
-        </p:txBody>
-      </p:sp>
-      <p:sp>
-        <p:nvSpPr>
-          <p:cNvPr id="28" name="TextBox 27"/>
-          <p:cNvSpPr txBox="1"/>
-          <p:nvPr/>
-        </p:nvSpPr>
-        <p:spPr>
-          <a:xfrm>
-            <a:off x="1005840" y="5239512"/>
-            <a:ext cx="3474720" cy="411480"/>
-          </a:xfrm>
-          <a:prstGeom prst="rect">
-            <a:avLst/>
-          </a:prstGeom>
-          <a:noFill/>
-        </p:spPr>
-        <p:txBody>
-          <a:bodyPr wrap="square" lIns="0" rIns="0" tIns="0" bIns="0" anchor="t">
-            <a:spAutoFit/>
-          </a:bodyPr>
-          <a:lstStyle/>
-          <a:p>
-            <a:pPr algn="l">
-              <a:lnSpc>
-                <a:spcPct val="105000"/>
-              </a:lnSpc>
-              <a:spcAft>
-                <a:spcPts val="0"/>
-              </a:spcAft>
-            </a:pPr>
-            <a:r>
-              <a:rPr sz="1050" b="0">
-                <a:solidFill>
-                  <a:srgbClr val="4A4D52"/>
-                </a:solidFill>
-                <a:latin typeface="Bahnschrift"/>
-              </a:rPr>
-              <a:t>RFID, UWB, pick-to-light and scan events, exported as JSON Lines.</a:t>
-            </a:r>
-          </a:p>
-        </p:txBody>
-      </p:sp>
-      <p:sp>
-        <p:nvSpPr>
-          <p:cNvPr id="29" name="TextBox 28"/>
-          <p:cNvSpPr txBox="1"/>
-          <p:nvPr/>
-        </p:nvSpPr>
-        <p:spPr>
-          <a:xfrm>
-            <a:off x="548640" y="5760720"/>
-            <a:ext cx="4023360" cy="274320"/>
-          </a:xfrm>
-          <a:prstGeom prst="rect">
-            <a:avLst/>
-          </a:prstGeom>
-          <a:noFill/>
-        </p:spPr>
-        <p:txBody>
-          <a:bodyPr wrap="square" lIns="0" rIns="0" tIns="0" bIns="0" anchor="t">
-            <a:spAutoFit/>
-          </a:bodyPr>
-          <a:lstStyle/>
-          <a:p>
-            <a:pPr algn="l">
-              <a:spcAft>
-                <a:spcPts val="0"/>
-              </a:spcAft>
-            </a:pPr>
-            <a:r>
-              <a:rPr sz="850" b="0">
-                <a:solidFill>
-                  <a:srgbClr val="7D786C"/>
-                </a:solidFill>
-                <a:latin typeface="Cascadia Mono"/>
-              </a:rPr>
-              <a:t>Space replay · 1–5 layouts · H heat · B batch · I IoT · O optimize</a:t>
+              <a:t>Same 2,293 orders, one queue; each picker takes the next trip at the dock. Deterministic, 0.5 s steps.</a:t>
             </a:r>
           </a:p>
         </p:txBody>
@@ -6520,7 +6778,7 @@
                 </a:solidFill>
                 <a:latin typeface="Cascadia Mono"/>
               </a:rPr>
-              <a:t> / 11</a:t>
+              <a:t> / 12</a:t>
             </a:r>
           </a:p>
         </p:txBody>
@@ -6699,8 +6957,8 @@
         </p:nvSpPr>
         <p:spPr>
           <a:xfrm>
-            <a:off x="10634472" y="548640"/>
-            <a:ext cx="1008583" cy="45720"/>
+            <a:off x="9793986" y="548640"/>
+            <a:ext cx="924534" cy="45720"/>
           </a:xfrm>
           <a:prstGeom prst="rect">
             <a:avLst/>
@@ -6770,6 +7028,1200 @@
                 <a:latin typeface="Cascadia Mono"/>
               </a:rPr>
               <a:t>§11  </a:t>
+            </a:r>
+            <a:r>
+              <a:rPr sz="1100" b="1" spc="220">
+                <a:solidFill>
+                  <a:srgbClr val="E0442A"/>
+                </a:solidFill>
+                <a:latin typeface="Bahnschrift SemiCondensed"/>
+              </a:rPr>
+              <a:t>PLAY IT</a:t>
+            </a:r>
+          </a:p>
+        </p:txBody>
+      </p:sp>
+      <p:sp>
+        <p:nvSpPr>
+          <p:cNvPr id="10" name="!!title"/>
+          <p:cNvSpPr txBox="1"/>
+          <p:nvPr/>
+        </p:nvSpPr>
+        <p:spPr>
+          <a:xfrm>
+            <a:off x="548640" y="1261872"/>
+            <a:ext cx="4206240" cy="1280160"/>
+          </a:xfrm>
+          <a:prstGeom prst="rect">
+            <a:avLst/>
+          </a:prstGeom>
+          <a:noFill/>
+        </p:spPr>
+        <p:txBody>
+          <a:bodyPr wrap="square" lIns="0" rIns="0" tIns="0" bIns="0" anchor="t">
+            <a:spAutoFit/>
+          </a:bodyPr>
+          <a:lstStyle/>
+          <a:p>
+            <a:pPr algn="l">
+              <a:lnSpc>
+                <a:spcPct val="92000"/>
+              </a:lnSpc>
+              <a:spcAft>
+                <a:spcPts val="0"/>
+              </a:spcAft>
+            </a:pPr>
+            <a:r>
+              <a:rPr sz="3600" b="0">
+                <a:solidFill>
+                  <a:srgbClr val="1F2226"/>
+                </a:solidFill>
+                <a:latin typeface="Bahnschrift SemiBold"/>
+              </a:rPr>
+              <a:t>Can you beat
+the optimizer?</a:t>
+            </a:r>
+          </a:p>
+        </p:txBody>
+      </p:sp>
+      <p:sp>
+        <p:nvSpPr>
+          <p:cNvPr id="11" name="Rectangle 10"/>
+          <p:cNvSpPr/>
+          <p:nvPr/>
+        </p:nvSpPr>
+        <p:spPr>
+          <a:xfrm>
+            <a:off x="4864608" y="978408"/>
+            <a:ext cx="6812280" cy="3831907"/>
+          </a:xfrm>
+          <a:prstGeom prst="rect">
+            <a:avLst/>
+          </a:prstGeom>
+          <a:solidFill>
+            <a:srgbClr val="1F2226"/>
+          </a:solidFill>
+          <a:ln>
+            <a:noFill/>
+          </a:ln>
+          <a:effectLst/>
+        </p:spPr>
+        <p:style>
+          <a:lnRef idx="1">
+            <a:schemeClr val="accent1"/>
+          </a:lnRef>
+          <a:fillRef idx="3">
+            <a:schemeClr val="accent1"/>
+          </a:fillRef>
+          <a:effectRef idx="2">
+            <a:schemeClr val="accent1"/>
+          </a:effectRef>
+          <a:fontRef idx="minor">
+            <a:schemeClr val="lt1"/>
+          </a:fontRef>
+        </p:style>
+        <p:txBody>
+          <a:bodyPr rtlCol="0" anchor="ctr"/>
+          <a:lstStyle/>
+          <a:p>
+            <a:pPr algn="ctr"/>
+          </a:p>
+        </p:txBody>
+      </p:sp>
+      <p:pic>
+        <p:nvPicPr>
+          <p:cNvPr id="12" name="!!hero" descr="app_game.jpg"/>
+          <p:cNvPicPr>
+            <a:picLocks noChangeAspect="1"/>
+          </p:cNvPicPr>
+          <p:nvPr/>
+        </p:nvPicPr>
+        <p:blipFill>
+          <a:blip r:embed="rId3"/>
+          <a:stretch>
+            <a:fillRect/>
+          </a:stretch>
+        </p:blipFill>
+        <p:spPr>
+          <a:xfrm>
+            <a:off x="4800600" y="914400"/>
+            <a:ext cx="6812280" cy="3831908"/>
+          </a:xfrm>
+          <a:prstGeom prst="rect">
+            <a:avLst/>
+          </a:prstGeom>
+          <a:ln w="12700">
+            <a:solidFill>
+              <a:srgbClr val="1F2226"/>
+            </a:solidFill>
+          </a:ln>
+        </p:spPr>
+      </p:pic>
+      <p:sp>
+        <p:nvSpPr>
+          <p:cNvPr id="13" name="Rectangle 12"/>
+          <p:cNvSpPr/>
+          <p:nvPr/>
+        </p:nvSpPr>
+        <p:spPr>
+          <a:xfrm>
+            <a:off x="548640" y="2514600"/>
+            <a:ext cx="3931920" cy="9525"/>
+          </a:xfrm>
+          <a:prstGeom prst="rect">
+            <a:avLst/>
+          </a:prstGeom>
+          <a:solidFill>
+            <a:srgbClr val="1F2226"/>
+          </a:solidFill>
+          <a:ln>
+            <a:noFill/>
+          </a:ln>
+          <a:effectLst/>
+        </p:spPr>
+        <p:style>
+          <a:lnRef idx="1">
+            <a:schemeClr val="accent1"/>
+          </a:lnRef>
+          <a:fillRef idx="3">
+            <a:schemeClr val="accent1"/>
+          </a:fillRef>
+          <a:effectRef idx="2">
+            <a:schemeClr val="accent1"/>
+          </a:effectRef>
+          <a:fontRef idx="minor">
+            <a:schemeClr val="lt1"/>
+          </a:fontRef>
+        </p:style>
+        <p:txBody>
+          <a:bodyPr rtlCol="0" anchor="ctr"/>
+          <a:lstStyle/>
+          <a:p>
+            <a:pPr algn="ctr"/>
+          </a:p>
+        </p:txBody>
+      </p:sp>
+      <p:sp>
+        <p:nvSpPr>
+          <p:cNvPr id="14" name="TextBox 13"/>
+          <p:cNvSpPr txBox="1"/>
+          <p:nvPr/>
+        </p:nvSpPr>
+        <p:spPr>
+          <a:xfrm>
+            <a:off x="548640" y="2606040"/>
+            <a:ext cx="457200" cy="274320"/>
+          </a:xfrm>
+          <a:prstGeom prst="rect">
+            <a:avLst/>
+          </a:prstGeom>
+          <a:noFill/>
+        </p:spPr>
+        <p:txBody>
+          <a:bodyPr wrap="square" lIns="0" rIns="0" tIns="0" bIns="0" anchor="t">
+            <a:spAutoFit/>
+          </a:bodyPr>
+          <a:lstStyle/>
+          <a:p>
+            <a:pPr algn="l">
+              <a:spcAft>
+                <a:spcPts val="0"/>
+              </a:spcAft>
+            </a:pPr>
+            <a:r>
+              <a:rPr sz="1000" b="0">
+                <a:solidFill>
+                  <a:srgbClr val="E0442A"/>
+                </a:solidFill>
+                <a:latin typeface="Cascadia Mono"/>
+              </a:rPr>
+              <a:t>01</a:t>
+            </a:r>
+          </a:p>
+        </p:txBody>
+      </p:sp>
+      <p:sp>
+        <p:nvSpPr>
+          <p:cNvPr id="15" name="TextBox 14"/>
+          <p:cNvSpPr txBox="1"/>
+          <p:nvPr/>
+        </p:nvSpPr>
+        <p:spPr>
+          <a:xfrm>
+            <a:off x="1005840" y="2578608"/>
+            <a:ext cx="3474720" cy="274320"/>
+          </a:xfrm>
+          <a:prstGeom prst="rect">
+            <a:avLst/>
+          </a:prstGeom>
+          <a:noFill/>
+        </p:spPr>
+        <p:txBody>
+          <a:bodyPr wrap="square" lIns="0" rIns="0" tIns="0" bIns="0" anchor="t">
+            <a:spAutoFit/>
+          </a:bodyPr>
+          <a:lstStyle/>
+          <a:p>
+            <a:pPr algn="l">
+              <a:spcAft>
+                <a:spcPts val="0"/>
+              </a:spcAft>
+            </a:pPr>
+            <a:r>
+              <a:rPr sz="1400" b="0">
+                <a:solidFill>
+                  <a:srgbClr val="1F2226"/>
+                </a:solidFill>
+                <a:latin typeface="Bahnschrift SemiBold"/>
+              </a:rPr>
+              <a:t>Swap racks</a:t>
+            </a:r>
+          </a:p>
+        </p:txBody>
+      </p:sp>
+      <p:sp>
+        <p:nvSpPr>
+          <p:cNvPr id="16" name="TextBox 15"/>
+          <p:cNvSpPr txBox="1"/>
+          <p:nvPr/>
+        </p:nvSpPr>
+        <p:spPr>
+          <a:xfrm>
+            <a:off x="1005840" y="2880360"/>
+            <a:ext cx="3474720" cy="411480"/>
+          </a:xfrm>
+          <a:prstGeom prst="rect">
+            <a:avLst/>
+          </a:prstGeom>
+          <a:noFill/>
+        </p:spPr>
+        <p:txBody>
+          <a:bodyPr wrap="square" lIns="0" rIns="0" tIns="0" bIns="0" anchor="t">
+            <a:spAutoFit/>
+          </a:bodyPr>
+          <a:lstStyle/>
+          <a:p>
+            <a:pPr algn="l">
+              <a:lnSpc>
+                <a:spcPct val="105000"/>
+              </a:lnSpc>
+              <a:spcAft>
+                <a:spcPts val="0"/>
+              </a:spcAft>
+            </a:pPr>
+            <a:r>
+              <a:rPr sz="1050" b="0">
+                <a:solidFill>
+                  <a:srgbClr val="4A4D52"/>
+                </a:solidFill>
+                <a:latin typeface="Bahnschrift"/>
+              </a:rPr>
+              <a:t>The month re-scores instantly; ◆ marks what is bought together.</a:t>
+            </a:r>
+          </a:p>
+        </p:txBody>
+      </p:sp>
+      <p:sp>
+        <p:nvSpPr>
+          <p:cNvPr id="17" name="Rectangle 16"/>
+          <p:cNvSpPr/>
+          <p:nvPr/>
+        </p:nvSpPr>
+        <p:spPr>
+          <a:xfrm>
+            <a:off x="548640" y="3300984"/>
+            <a:ext cx="3931920" cy="9525"/>
+          </a:xfrm>
+          <a:prstGeom prst="rect">
+            <a:avLst/>
+          </a:prstGeom>
+          <a:solidFill>
+            <a:srgbClr val="D3CAB8"/>
+          </a:solidFill>
+          <a:ln>
+            <a:noFill/>
+          </a:ln>
+          <a:effectLst/>
+        </p:spPr>
+        <p:style>
+          <a:lnRef idx="1">
+            <a:schemeClr val="accent1"/>
+          </a:lnRef>
+          <a:fillRef idx="3">
+            <a:schemeClr val="accent1"/>
+          </a:fillRef>
+          <a:effectRef idx="2">
+            <a:schemeClr val="accent1"/>
+          </a:effectRef>
+          <a:fontRef idx="minor">
+            <a:schemeClr val="lt1"/>
+          </a:fontRef>
+        </p:style>
+        <p:txBody>
+          <a:bodyPr rtlCol="0" anchor="ctr"/>
+          <a:lstStyle/>
+          <a:p>
+            <a:pPr algn="ctr"/>
+          </a:p>
+        </p:txBody>
+      </p:sp>
+      <p:sp>
+        <p:nvSpPr>
+          <p:cNvPr id="18" name="TextBox 17"/>
+          <p:cNvSpPr txBox="1"/>
+          <p:nvPr/>
+        </p:nvSpPr>
+        <p:spPr>
+          <a:xfrm>
+            <a:off x="548640" y="3392424"/>
+            <a:ext cx="457200" cy="274320"/>
+          </a:xfrm>
+          <a:prstGeom prst="rect">
+            <a:avLst/>
+          </a:prstGeom>
+          <a:noFill/>
+        </p:spPr>
+        <p:txBody>
+          <a:bodyPr wrap="square" lIns="0" rIns="0" tIns="0" bIns="0" anchor="t">
+            <a:spAutoFit/>
+          </a:bodyPr>
+          <a:lstStyle/>
+          <a:p>
+            <a:pPr algn="l">
+              <a:spcAft>
+                <a:spcPts val="0"/>
+              </a:spcAft>
+            </a:pPr>
+            <a:r>
+              <a:rPr sz="1000" b="0">
+                <a:solidFill>
+                  <a:srgbClr val="E0442A"/>
+                </a:solidFill>
+                <a:latin typeface="Cascadia Mono"/>
+              </a:rPr>
+              <a:t>02</a:t>
+            </a:r>
+          </a:p>
+        </p:txBody>
+      </p:sp>
+      <p:sp>
+        <p:nvSpPr>
+          <p:cNvPr id="19" name="TextBox 18"/>
+          <p:cNvSpPr txBox="1"/>
+          <p:nvPr/>
+        </p:nvSpPr>
+        <p:spPr>
+          <a:xfrm>
+            <a:off x="1005840" y="3364991"/>
+            <a:ext cx="3474720" cy="274320"/>
+          </a:xfrm>
+          <a:prstGeom prst="rect">
+            <a:avLst/>
+          </a:prstGeom>
+          <a:noFill/>
+        </p:spPr>
+        <p:txBody>
+          <a:bodyPr wrap="square" lIns="0" rIns="0" tIns="0" bIns="0" anchor="t">
+            <a:spAutoFit/>
+          </a:bodyPr>
+          <a:lstStyle/>
+          <a:p>
+            <a:pPr algn="l">
+              <a:spcAft>
+                <a:spcPts val="0"/>
+              </a:spcAft>
+            </a:pPr>
+            <a:r>
+              <a:rPr sz="1400" b="0">
+                <a:solidFill>
+                  <a:srgbClr val="1F2226"/>
+                </a:solidFill>
+                <a:latin typeface="Bahnschrift SemiBold"/>
+              </a:rPr>
+              <a:t>Live optimizer</a:t>
+            </a:r>
+          </a:p>
+        </p:txBody>
+      </p:sp>
+      <p:sp>
+        <p:nvSpPr>
+          <p:cNvPr id="20" name="TextBox 19"/>
+          <p:cNvSpPr txBox="1"/>
+          <p:nvPr/>
+        </p:nvSpPr>
+        <p:spPr>
+          <a:xfrm>
+            <a:off x="1005840" y="3666744"/>
+            <a:ext cx="3474720" cy="411480"/>
+          </a:xfrm>
+          <a:prstGeom prst="rect">
+            <a:avLst/>
+          </a:prstGeom>
+          <a:noFill/>
+        </p:spPr>
+        <p:txBody>
+          <a:bodyPr wrap="square" lIns="0" rIns="0" tIns="0" bIns="0" anchor="t">
+            <a:spAutoFit/>
+          </a:bodyPr>
+          <a:lstStyle/>
+          <a:p>
+            <a:pPr algn="l">
+              <a:lnSpc>
+                <a:spcPct val="105000"/>
+              </a:lnSpc>
+              <a:spcAft>
+                <a:spcPts val="0"/>
+              </a:spcAft>
+            </a:pPr>
+            <a:r>
+              <a:rPr sz="1050" b="0">
+                <a:solidFill>
+                  <a:srgbClr val="4A4D52"/>
+                </a:solidFill>
+                <a:latin typeface="Bahnschrift"/>
+              </a:rPr>
+              <a:t>Annealing in a Web Worker on your layout. Here: 182.3 km in 14 s.</a:t>
+            </a:r>
+          </a:p>
+        </p:txBody>
+      </p:sp>
+      <p:sp>
+        <p:nvSpPr>
+          <p:cNvPr id="21" name="Rectangle 20"/>
+          <p:cNvSpPr/>
+          <p:nvPr/>
+        </p:nvSpPr>
+        <p:spPr>
+          <a:xfrm>
+            <a:off x="548640" y="4087368"/>
+            <a:ext cx="3931920" cy="9525"/>
+          </a:xfrm>
+          <a:prstGeom prst="rect">
+            <a:avLst/>
+          </a:prstGeom>
+          <a:solidFill>
+            <a:srgbClr val="D3CAB8"/>
+          </a:solidFill>
+          <a:ln>
+            <a:noFill/>
+          </a:ln>
+          <a:effectLst/>
+        </p:spPr>
+        <p:style>
+          <a:lnRef idx="1">
+            <a:schemeClr val="accent1"/>
+          </a:lnRef>
+          <a:fillRef idx="3">
+            <a:schemeClr val="accent1"/>
+          </a:fillRef>
+          <a:effectRef idx="2">
+            <a:schemeClr val="accent1"/>
+          </a:effectRef>
+          <a:fontRef idx="minor">
+            <a:schemeClr val="lt1"/>
+          </a:fontRef>
+        </p:style>
+        <p:txBody>
+          <a:bodyPr rtlCol="0" anchor="ctr"/>
+          <a:lstStyle/>
+          <a:p>
+            <a:pPr algn="ctr"/>
+          </a:p>
+        </p:txBody>
+      </p:sp>
+      <p:sp>
+        <p:nvSpPr>
+          <p:cNvPr id="22" name="TextBox 21"/>
+          <p:cNvSpPr txBox="1"/>
+          <p:nvPr/>
+        </p:nvSpPr>
+        <p:spPr>
+          <a:xfrm>
+            <a:off x="548640" y="4178807"/>
+            <a:ext cx="457200" cy="274320"/>
+          </a:xfrm>
+          <a:prstGeom prst="rect">
+            <a:avLst/>
+          </a:prstGeom>
+          <a:noFill/>
+        </p:spPr>
+        <p:txBody>
+          <a:bodyPr wrap="square" lIns="0" rIns="0" tIns="0" bIns="0" anchor="t">
+            <a:spAutoFit/>
+          </a:bodyPr>
+          <a:lstStyle/>
+          <a:p>
+            <a:pPr algn="l">
+              <a:spcAft>
+                <a:spcPts val="0"/>
+              </a:spcAft>
+            </a:pPr>
+            <a:r>
+              <a:rPr sz="1000" b="0">
+                <a:solidFill>
+                  <a:srgbClr val="E0442A"/>
+                </a:solidFill>
+                <a:latin typeface="Cascadia Mono"/>
+              </a:rPr>
+              <a:t>03</a:t>
+            </a:r>
+          </a:p>
+        </p:txBody>
+      </p:sp>
+      <p:sp>
+        <p:nvSpPr>
+          <p:cNvPr id="23" name="TextBox 22"/>
+          <p:cNvSpPr txBox="1"/>
+          <p:nvPr/>
+        </p:nvSpPr>
+        <p:spPr>
+          <a:xfrm>
+            <a:off x="1005840" y="4151376"/>
+            <a:ext cx="3474720" cy="274320"/>
+          </a:xfrm>
+          <a:prstGeom prst="rect">
+            <a:avLst/>
+          </a:prstGeom>
+          <a:noFill/>
+        </p:spPr>
+        <p:txBody>
+          <a:bodyPr wrap="square" lIns="0" rIns="0" tIns="0" bIns="0" anchor="t">
+            <a:spAutoFit/>
+          </a:bodyPr>
+          <a:lstStyle/>
+          <a:p>
+            <a:pPr algn="l">
+              <a:spcAft>
+                <a:spcPts val="0"/>
+              </a:spcAft>
+            </a:pPr>
+            <a:r>
+              <a:rPr sz="1400" b="0">
+                <a:solidFill>
+                  <a:srgbClr val="1F2226"/>
+                </a:solidFill>
+                <a:latin typeface="Bahnschrift SemiBold"/>
+              </a:rPr>
+              <a:t>Team mode</a:t>
+            </a:r>
+          </a:p>
+        </p:txBody>
+      </p:sp>
+      <p:sp>
+        <p:nvSpPr>
+          <p:cNvPr id="24" name="TextBox 23"/>
+          <p:cNvSpPr txBox="1"/>
+          <p:nvPr/>
+        </p:nvSpPr>
+        <p:spPr>
+          <a:xfrm>
+            <a:off x="1005840" y="4453128"/>
+            <a:ext cx="3474720" cy="411480"/>
+          </a:xfrm>
+          <a:prstGeom prst="rect">
+            <a:avLst/>
+          </a:prstGeom>
+          <a:noFill/>
+        </p:spPr>
+        <p:txBody>
+          <a:bodyPr wrap="square" lIns="0" rIns="0" tIns="0" bIns="0" anchor="t">
+            <a:spAutoFit/>
+          </a:bodyPr>
+          <a:lstStyle/>
+          <a:p>
+            <a:pPr algn="l">
+              <a:lnSpc>
+                <a:spcPct val="105000"/>
+              </a:lnSpc>
+              <a:spcAft>
+                <a:spcPts val="0"/>
+              </a:spcAft>
+            </a:pPr>
+            <a:r>
+              <a:rPr sz="1050" b="0">
+                <a:solidFill>
+                  <a:srgbClr val="4A4D52"/>
+                </a:solidFill>
+                <a:latin typeface="Bahnschrift"/>
+              </a:rPr>
+              <a:t>1–6 pickers with aisle congestion; watch them queue.</a:t>
+            </a:r>
+          </a:p>
+        </p:txBody>
+      </p:sp>
+      <p:sp>
+        <p:nvSpPr>
+          <p:cNvPr id="25" name="Rectangle 24"/>
+          <p:cNvSpPr/>
+          <p:nvPr/>
+        </p:nvSpPr>
+        <p:spPr>
+          <a:xfrm>
+            <a:off x="548640" y="4873752"/>
+            <a:ext cx="3931920" cy="9525"/>
+          </a:xfrm>
+          <a:prstGeom prst="rect">
+            <a:avLst/>
+          </a:prstGeom>
+          <a:solidFill>
+            <a:srgbClr val="D3CAB8"/>
+          </a:solidFill>
+          <a:ln>
+            <a:noFill/>
+          </a:ln>
+          <a:effectLst/>
+        </p:spPr>
+        <p:style>
+          <a:lnRef idx="1">
+            <a:schemeClr val="accent1"/>
+          </a:lnRef>
+          <a:fillRef idx="3">
+            <a:schemeClr val="accent1"/>
+          </a:fillRef>
+          <a:effectRef idx="2">
+            <a:schemeClr val="accent1"/>
+          </a:effectRef>
+          <a:fontRef idx="minor">
+            <a:schemeClr val="lt1"/>
+          </a:fontRef>
+        </p:style>
+        <p:txBody>
+          <a:bodyPr rtlCol="0" anchor="ctr"/>
+          <a:lstStyle/>
+          <a:p>
+            <a:pPr algn="ctr"/>
+          </a:p>
+        </p:txBody>
+      </p:sp>
+      <p:sp>
+        <p:nvSpPr>
+          <p:cNvPr id="26" name="TextBox 25"/>
+          <p:cNvSpPr txBox="1"/>
+          <p:nvPr/>
+        </p:nvSpPr>
+        <p:spPr>
+          <a:xfrm>
+            <a:off x="548640" y="4965192"/>
+            <a:ext cx="457200" cy="274320"/>
+          </a:xfrm>
+          <a:prstGeom prst="rect">
+            <a:avLst/>
+          </a:prstGeom>
+          <a:noFill/>
+        </p:spPr>
+        <p:txBody>
+          <a:bodyPr wrap="square" lIns="0" rIns="0" tIns="0" bIns="0" anchor="t">
+            <a:spAutoFit/>
+          </a:bodyPr>
+          <a:lstStyle/>
+          <a:p>
+            <a:pPr algn="l">
+              <a:spcAft>
+                <a:spcPts val="0"/>
+              </a:spcAft>
+            </a:pPr>
+            <a:r>
+              <a:rPr sz="1000" b="0">
+                <a:solidFill>
+                  <a:srgbClr val="E0442A"/>
+                </a:solidFill>
+                <a:latin typeface="Cascadia Mono"/>
+              </a:rPr>
+              <a:t>04</a:t>
+            </a:r>
+          </a:p>
+        </p:txBody>
+      </p:sp>
+      <p:sp>
+        <p:nvSpPr>
+          <p:cNvPr id="27" name="TextBox 26"/>
+          <p:cNvSpPr txBox="1"/>
+          <p:nvPr/>
+        </p:nvSpPr>
+        <p:spPr>
+          <a:xfrm>
+            <a:off x="1005840" y="4937760"/>
+            <a:ext cx="3474720" cy="274320"/>
+          </a:xfrm>
+          <a:prstGeom prst="rect">
+            <a:avLst/>
+          </a:prstGeom>
+          <a:noFill/>
+        </p:spPr>
+        <p:txBody>
+          <a:bodyPr wrap="square" lIns="0" rIns="0" tIns="0" bIns="0" anchor="t">
+            <a:spAutoFit/>
+          </a:bodyPr>
+          <a:lstStyle/>
+          <a:p>
+            <a:pPr algn="l">
+              <a:spcAft>
+                <a:spcPts val="0"/>
+              </a:spcAft>
+            </a:pPr>
+            <a:r>
+              <a:rPr sz="1400" b="0">
+                <a:solidFill>
+                  <a:srgbClr val="1F2226"/>
+                </a:solidFill>
+                <a:latin typeface="Bahnschrift SemiBold"/>
+              </a:rPr>
+              <a:t>IoT sensor mode</a:t>
+            </a:r>
+          </a:p>
+        </p:txBody>
+      </p:sp>
+      <p:sp>
+        <p:nvSpPr>
+          <p:cNvPr id="28" name="TextBox 27"/>
+          <p:cNvSpPr txBox="1"/>
+          <p:nvPr/>
+        </p:nvSpPr>
+        <p:spPr>
+          <a:xfrm>
+            <a:off x="1005840" y="5239512"/>
+            <a:ext cx="3474720" cy="411480"/>
+          </a:xfrm>
+          <a:prstGeom prst="rect">
+            <a:avLst/>
+          </a:prstGeom>
+          <a:noFill/>
+        </p:spPr>
+        <p:txBody>
+          <a:bodyPr wrap="square" lIns="0" rIns="0" tIns="0" bIns="0" anchor="t">
+            <a:spAutoFit/>
+          </a:bodyPr>
+          <a:lstStyle/>
+          <a:p>
+            <a:pPr algn="l">
+              <a:lnSpc>
+                <a:spcPct val="105000"/>
+              </a:lnSpc>
+              <a:spcAft>
+                <a:spcPts val="0"/>
+              </a:spcAft>
+            </a:pPr>
+            <a:r>
+              <a:rPr sz="1050" b="0">
+                <a:solidFill>
+                  <a:srgbClr val="4A4D52"/>
+                </a:solidFill>
+                <a:latin typeface="Bahnschrift"/>
+              </a:rPr>
+              <a:t>RFID, UWB, pick-to-light and scan events, exported as JSON Lines.</a:t>
+            </a:r>
+          </a:p>
+        </p:txBody>
+      </p:sp>
+      <p:sp>
+        <p:nvSpPr>
+          <p:cNvPr id="29" name="TextBox 28"/>
+          <p:cNvSpPr txBox="1"/>
+          <p:nvPr/>
+        </p:nvSpPr>
+        <p:spPr>
+          <a:xfrm>
+            <a:off x="548640" y="5760720"/>
+            <a:ext cx="4023360" cy="274320"/>
+          </a:xfrm>
+          <a:prstGeom prst="rect">
+            <a:avLst/>
+          </a:prstGeom>
+          <a:noFill/>
+        </p:spPr>
+        <p:txBody>
+          <a:bodyPr wrap="square" lIns="0" rIns="0" tIns="0" bIns="0" anchor="t">
+            <a:spAutoFit/>
+          </a:bodyPr>
+          <a:lstStyle/>
+          <a:p>
+            <a:pPr algn="l">
+              <a:spcAft>
+                <a:spcPts val="0"/>
+              </a:spcAft>
+            </a:pPr>
+            <a:r>
+              <a:rPr sz="850" b="0">
+                <a:solidFill>
+                  <a:srgbClr val="7D786C"/>
+                </a:solidFill>
+                <a:latin typeface="Cascadia Mono"/>
+              </a:rPr>
+              <a:t>Space replay · 1–5 layouts · H heat · B batch · I IoT · O optimize</a:t>
+            </a:r>
+          </a:p>
+        </p:txBody>
+      </p:sp>
+    </p:spTree>
+  </p:cSld>
+  <p:clrMapOvr>
+    <a:masterClrMapping/>
+  </p:clrMapOvr>
+  <mc:AlternateContent xmlns:mc="http://schemas.openxmlformats.org/markup-compatibility/2006">
+    <mc:Choice xmlns:p159="http://schemas.microsoft.com/office/powerpoint/2015/09/main" xmlns:p14="http://schemas.microsoft.com/office/powerpoint/2010/main" Requires="p159">
+      <p:transition spd="slow" p14:dur="1100">
+        <p159:morph option="byObject"/>
+      </p:transition>
+    </mc:Choice>
+    <mc:Fallback>
+      <p:transition spd="slow">
+        <p:fade/>
+      </p:transition>
+    </mc:Fallback>
+  </mc:AlternateContent>
+</p:sld>
+</file>
+
+<file path=ppt/slides/slide12.xml><?xml version="1.0" encoding="utf-8"?>
+<p:sld xmlns:a="http://schemas.openxmlformats.org/drawingml/2006/main" xmlns:p="http://schemas.openxmlformats.org/presentationml/2006/main" xmlns:r="http://schemas.openxmlformats.org/officeDocument/2006/relationships">
+  <p:cSld>
+    <p:bg>
+      <p:bgPr>
+        <a:solidFill>
+          <a:srgbClr val="F1EADB"/>
+        </a:solidFill>
+        <a:effectLst/>
+      </p:bgPr>
+    </p:bg>
+    <p:spTree>
+      <p:nvGrpSpPr>
+        <p:cNvPr id="1" name=""/>
+        <p:cNvGrpSpPr/>
+        <p:nvPr/>
+      </p:nvGrpSpPr>
+      <p:grpSpPr/>
+      <p:sp>
+        <p:nvSpPr>
+          <p:cNvPr id="2" name="!!run"/>
+          <p:cNvSpPr txBox="1"/>
+          <p:nvPr/>
+        </p:nvSpPr>
+        <p:spPr>
+          <a:xfrm>
+            <a:off x="548640" y="310896"/>
+            <a:ext cx="6400800" cy="228600"/>
+          </a:xfrm>
+          <a:prstGeom prst="rect">
+            <a:avLst/>
+          </a:prstGeom>
+          <a:noFill/>
+        </p:spPr>
+        <p:txBody>
+          <a:bodyPr wrap="square" lIns="0" rIns="0" tIns="0" bIns="0" anchor="t">
+            <a:spAutoFit/>
+          </a:bodyPr>
+          <a:lstStyle/>
+          <a:p>
+            <a:pPr algn="l">
+              <a:spcAft>
+                <a:spcPts val="0"/>
+              </a:spcAft>
+            </a:pPr>
+            <a:r>
+              <a:rPr sz="850" b="0" spc="120">
+                <a:solidFill>
+                  <a:srgbClr val="4A4D52"/>
+                </a:solidFill>
+                <a:latin typeface="Cascadia Mono"/>
+              </a:rPr>
+              <a:t>PICKING FLOOR DIGITAL TWIN</a:t>
+            </a:r>
+          </a:p>
+        </p:txBody>
+      </p:sp>
+      <p:sp>
+        <p:nvSpPr>
+          <p:cNvPr id="3" name="!!pno"/>
+          <p:cNvSpPr txBox="1"/>
+          <p:nvPr/>
+        </p:nvSpPr>
+        <p:spPr>
+          <a:xfrm>
+            <a:off x="8899855" y="310896"/>
+            <a:ext cx="2743200" cy="228600"/>
+          </a:xfrm>
+          <a:prstGeom prst="rect">
+            <a:avLst/>
+          </a:prstGeom>
+          <a:noFill/>
+        </p:spPr>
+        <p:txBody>
+          <a:bodyPr wrap="square" lIns="0" rIns="0" tIns="0" bIns="0" anchor="t">
+            <a:spAutoFit/>
+          </a:bodyPr>
+          <a:lstStyle/>
+          <a:p>
+            <a:pPr algn="r">
+              <a:spcAft>
+                <a:spcPts val="0"/>
+              </a:spcAft>
+            </a:pPr>
+            <a:r>
+              <a:rPr sz="850" b="0">
+                <a:solidFill>
+                  <a:srgbClr val="E0442A"/>
+                </a:solidFill>
+                <a:latin typeface="Cascadia Mono"/>
+              </a:rPr>
+              <a:t>12</a:t>
+            </a:r>
+            <a:r>
+              <a:rPr sz="850" b="0">
+                <a:solidFill>
+                  <a:srgbClr val="4A4D52"/>
+                </a:solidFill>
+                <a:latin typeface="Cascadia Mono"/>
+              </a:rPr>
+              <a:t> / 12</a:t>
+            </a:r>
+          </a:p>
+        </p:txBody>
+      </p:sp>
+      <p:sp>
+        <p:nvSpPr>
+          <p:cNvPr id="4" name="!!rule"/>
+          <p:cNvSpPr/>
+          <p:nvPr/>
+        </p:nvSpPr>
+        <p:spPr>
+          <a:xfrm>
+            <a:off x="548640" y="566928"/>
+            <a:ext cx="11094415" cy="9525"/>
+          </a:xfrm>
+          <a:prstGeom prst="rect">
+            <a:avLst/>
+          </a:prstGeom>
+          <a:solidFill>
+            <a:srgbClr val="1F2226"/>
+          </a:solidFill>
+          <a:ln>
+            <a:noFill/>
+          </a:ln>
+          <a:effectLst/>
+        </p:spPr>
+        <p:style>
+          <a:lnRef idx="1">
+            <a:schemeClr val="accent1"/>
+          </a:lnRef>
+          <a:fillRef idx="3">
+            <a:schemeClr val="accent1"/>
+          </a:fillRef>
+          <a:effectRef idx="2">
+            <a:schemeClr val="accent1"/>
+          </a:effectRef>
+          <a:fontRef idx="minor">
+            <a:schemeClr val="lt1"/>
+          </a:fontRef>
+        </p:style>
+        <p:txBody>
+          <a:bodyPr rtlCol="0" anchor="ctr"/>
+          <a:lstStyle/>
+          <a:p>
+            <a:pPr algn="ctr"/>
+          </a:p>
+        </p:txBody>
+      </p:sp>
+      <p:sp>
+        <p:nvSpPr>
+          <p:cNvPr id="5" name="!!foot"/>
+          <p:cNvSpPr/>
+          <p:nvPr/>
+        </p:nvSpPr>
+        <p:spPr>
+          <a:xfrm>
+            <a:off x="548640" y="6382512"/>
+            <a:ext cx="11094415" cy="9525"/>
+          </a:xfrm>
+          <a:prstGeom prst="rect">
+            <a:avLst/>
+          </a:prstGeom>
+          <a:solidFill>
+            <a:srgbClr val="D3CAB8"/>
+          </a:solidFill>
+          <a:ln>
+            <a:noFill/>
+          </a:ln>
+          <a:effectLst/>
+        </p:spPr>
+        <p:style>
+          <a:lnRef idx="1">
+            <a:schemeClr val="accent1"/>
+          </a:lnRef>
+          <a:fillRef idx="3">
+            <a:schemeClr val="accent1"/>
+          </a:fillRef>
+          <a:effectRef idx="2">
+            <a:schemeClr val="accent1"/>
+          </a:effectRef>
+          <a:fontRef idx="minor">
+            <a:schemeClr val="lt1"/>
+          </a:fontRef>
+        </p:style>
+        <p:txBody>
+          <a:bodyPr rtlCol="0" anchor="ctr"/>
+          <a:lstStyle/>
+          <a:p>
+            <a:pPr algn="ctr"/>
+          </a:p>
+        </p:txBody>
+      </p:sp>
+      <p:sp>
+        <p:nvSpPr>
+          <p:cNvPr id="6" name="!!foottxt"/>
+          <p:cNvSpPr txBox="1"/>
+          <p:nvPr/>
+        </p:nvSpPr>
+        <p:spPr>
+          <a:xfrm>
+            <a:off x="548640" y="6473952"/>
+            <a:ext cx="7315200" cy="201168"/>
+          </a:xfrm>
+          <a:prstGeom prst="rect">
+            <a:avLst/>
+          </a:prstGeom>
+          <a:noFill/>
+        </p:spPr>
+        <p:txBody>
+          <a:bodyPr wrap="square" lIns="0" rIns="0" tIns="0" bIns="0" anchor="t">
+            <a:spAutoFit/>
+          </a:bodyPr>
+          <a:lstStyle/>
+          <a:p>
+            <a:pPr algn="l">
+              <a:spcAft>
+                <a:spcPts val="0"/>
+              </a:spcAft>
+            </a:pPr>
+            <a:r>
+              <a:rPr sz="750" b="0" spc="80">
+                <a:solidFill>
+                  <a:srgbClr val="7D786C"/>
+                </a:solidFill>
+                <a:latin typeface="Cascadia Mono"/>
+              </a:rPr>
+              <a:t>ELECTRO-SOLVE 2026  ·  PS 4.2  ·  SENSE, VIT</a:t>
+            </a:r>
+          </a:p>
+        </p:txBody>
+      </p:sp>
+      <p:sp>
+        <p:nvSpPr>
+          <p:cNvPr id="7" name="!!src"/>
+          <p:cNvSpPr txBox="1"/>
+          <p:nvPr/>
+        </p:nvSpPr>
+        <p:spPr>
+          <a:xfrm>
+            <a:off x="7071055" y="6473952"/>
+            <a:ext cx="4572000" cy="201168"/>
+          </a:xfrm>
+          <a:prstGeom prst="rect">
+            <a:avLst/>
+          </a:prstGeom>
+          <a:noFill/>
+        </p:spPr>
+        <p:txBody>
+          <a:bodyPr wrap="square" lIns="0" rIns="0" tIns="0" bIns="0" anchor="t">
+            <a:spAutoFit/>
+          </a:bodyPr>
+          <a:lstStyle/>
+          <a:p>
+            <a:pPr algn="r">
+              <a:spcAft>
+                <a:spcPts val="0"/>
+              </a:spcAft>
+            </a:pPr>
+            <a:r>
+              <a:rPr sz="750" b="0" spc="80">
+                <a:solidFill>
+                  <a:srgbClr val="7D786C"/>
+                </a:solidFill>
+                <a:latin typeface="Cascadia Mono"/>
+              </a:rPr>
+              <a:t>DATA: ONLINE RETAIL II (UCI, CC BY 4.0)</a:t>
+            </a:r>
+          </a:p>
+        </p:txBody>
+      </p:sp>
+      <p:sp>
+        <p:nvSpPr>
+          <p:cNvPr id="8" name="!!prog"/>
+          <p:cNvSpPr/>
+          <p:nvPr/>
+        </p:nvSpPr>
+        <p:spPr>
+          <a:xfrm>
+            <a:off x="10718520" y="548640"/>
+            <a:ext cx="924534" cy="45720"/>
+          </a:xfrm>
+          <a:prstGeom prst="rect">
+            <a:avLst/>
+          </a:prstGeom>
+          <a:solidFill>
+            <a:srgbClr val="E0442A"/>
+          </a:solidFill>
+          <a:ln>
+            <a:noFill/>
+          </a:ln>
+          <a:effectLst/>
+        </p:spPr>
+        <p:style>
+          <a:lnRef idx="1">
+            <a:schemeClr val="accent1"/>
+          </a:lnRef>
+          <a:fillRef idx="3">
+            <a:schemeClr val="accent1"/>
+          </a:fillRef>
+          <a:effectRef idx="2">
+            <a:schemeClr val="accent1"/>
+          </a:effectRef>
+          <a:fontRef idx="minor">
+            <a:schemeClr val="lt1"/>
+          </a:fontRef>
+        </p:style>
+        <p:txBody>
+          <a:bodyPr rtlCol="0" anchor="ctr"/>
+          <a:lstStyle/>
+          <a:p>
+            <a:pPr algn="ctr"/>
+          </a:p>
+        </p:txBody>
+      </p:sp>
+      <p:sp>
+        <p:nvSpPr>
+          <p:cNvPr id="9" name="!!kicker"/>
+          <p:cNvSpPr txBox="1"/>
+          <p:nvPr/>
+        </p:nvSpPr>
+        <p:spPr>
+          <a:xfrm>
+            <a:off x="548640" y="914400"/>
+            <a:ext cx="7315200" cy="274320"/>
+          </a:xfrm>
+          <a:prstGeom prst="rect">
+            <a:avLst/>
+          </a:prstGeom>
+          <a:noFill/>
+        </p:spPr>
+        <p:txBody>
+          <a:bodyPr wrap="square" lIns="0" rIns="0" tIns="0" bIns="0" anchor="t">
+            <a:spAutoFit/>
+          </a:bodyPr>
+          <a:lstStyle/>
+          <a:p>
+            <a:pPr algn="l">
+              <a:spcAft>
+                <a:spcPts val="0"/>
+              </a:spcAft>
+            </a:pPr>
+            <a:r>
+              <a:rPr sz="1100" b="1">
+                <a:solidFill>
+                  <a:srgbClr val="7D786C"/>
+                </a:solidFill>
+                <a:latin typeface="Cascadia Mono"/>
+              </a:rPr>
+              <a:t>§12  </a:t>
             </a:r>
             <a:r>
               <a:rPr sz="1100" b="1" spc="220">
@@ -7546,7 +8998,7 @@
                 </a:solidFill>
                 <a:latin typeface="Bahnschrift"/>
               </a:rPr>
-              <a:t>Next: several pickers and aisle congestion.</a:t>
+              <a:t>Next: live sensor input and dynamic re-slotting.</a:t>
             </a:r>
           </a:p>
         </p:txBody>
@@ -7671,7 +9123,7 @@
                 </a:solidFill>
                 <a:latin typeface="Cascadia Mono"/>
               </a:rPr>
-              <a:t> / 11</a:t>
+              <a:t> / 12</a:t>
             </a:r>
           </a:p>
         </p:txBody>
@@ -7850,8 +9302,8 @@
         </p:nvSpPr>
         <p:spPr>
           <a:xfrm>
-            <a:off x="1557223" y="548640"/>
-            <a:ext cx="1008583" cy="45720"/>
+            <a:off x="1473174" y="548640"/>
+            <a:ext cx="924534" cy="45720"/>
           </a:xfrm>
           <a:prstGeom prst="rect">
             <a:avLst/>
@@ -8503,7 +9955,7 @@
                 </a:solidFill>
                 <a:latin typeface="Cascadia Mono"/>
               </a:rPr>
-              <a:t> / 11</a:t>
+              <a:t> / 12</a:t>
             </a:r>
           </a:p>
         </p:txBody>
@@ -8682,8 +10134,8 @@
         </p:nvSpPr>
         <p:spPr>
           <a:xfrm>
-            <a:off x="2565806" y="548640"/>
-            <a:ext cx="1008583" cy="45720"/>
+            <a:off x="2397709" y="548640"/>
+            <a:ext cx="924534" cy="45720"/>
           </a:xfrm>
           <a:prstGeom prst="rect">
             <a:avLst/>
@@ -9984,7 +11436,7 @@
                 </a:solidFill>
                 <a:latin typeface="Cascadia Mono"/>
               </a:rPr>
-              <a:t> / 11</a:t>
+              <a:t> / 12</a:t>
             </a:r>
           </a:p>
         </p:txBody>
@@ -10163,8 +11615,8 @@
         </p:nvSpPr>
         <p:spPr>
           <a:xfrm>
-            <a:off x="3574389" y="548640"/>
-            <a:ext cx="1008583" cy="45720"/>
+            <a:off x="3322243" y="548640"/>
+            <a:ext cx="924534" cy="45720"/>
           </a:xfrm>
           <a:prstGeom prst="rect">
             <a:avLst/>
@@ -11199,7 +12651,7 @@
                 </a:solidFill>
                 <a:latin typeface="Cascadia Mono"/>
               </a:rPr>
-              <a:t> / 11</a:t>
+              <a:t> / 12</a:t>
             </a:r>
           </a:p>
         </p:txBody>
@@ -11378,8 +12830,8 @@
         </p:nvSpPr>
         <p:spPr>
           <a:xfrm>
-            <a:off x="4582972" y="548640"/>
-            <a:ext cx="1008583" cy="45720"/>
+            <a:off x="4246778" y="548640"/>
+            <a:ext cx="924534" cy="45720"/>
           </a:xfrm>
           <a:prstGeom prst="rect">
             <a:avLst/>
@@ -12736,7 +14188,7 @@
                 </a:solidFill>
                 <a:latin typeface="Cascadia Mono"/>
               </a:rPr>
-              <a:t> / 11</a:t>
+              <a:t> / 12</a:t>
             </a:r>
           </a:p>
         </p:txBody>
@@ -12915,8 +14367,8 @@
         </p:nvSpPr>
         <p:spPr>
           <a:xfrm>
-            <a:off x="5591556" y="548640"/>
-            <a:ext cx="1008583" cy="45720"/>
+            <a:off x="5171313" y="548640"/>
+            <a:ext cx="924534" cy="45720"/>
           </a:xfrm>
           <a:prstGeom prst="rect">
             <a:avLst/>
@@ -14273,7 +15725,7 @@
                 </a:solidFill>
                 <a:latin typeface="Cascadia Mono"/>
               </a:rPr>
-              <a:t> / 11</a:t>
+              <a:t> / 12</a:t>
             </a:r>
           </a:p>
         </p:txBody>
@@ -14452,8 +15904,8 @@
         </p:nvSpPr>
         <p:spPr>
           <a:xfrm>
-            <a:off x="6600139" y="548640"/>
-            <a:ext cx="1008583" cy="45720"/>
+            <a:off x="6095847" y="548640"/>
+            <a:ext cx="924534" cy="45720"/>
           </a:xfrm>
           <a:prstGeom prst="rect">
             <a:avLst/>
@@ -15810,7 +17262,7 @@
                 </a:solidFill>
                 <a:latin typeface="Cascadia Mono"/>
               </a:rPr>
-              <a:t> / 11</a:t>
+              <a:t> / 12</a:t>
             </a:r>
           </a:p>
         </p:txBody>
@@ -15989,8 +17441,8 @@
         </p:nvSpPr>
         <p:spPr>
           <a:xfrm>
-            <a:off x="7608722" y="548640"/>
-            <a:ext cx="1008583" cy="45720"/>
+            <a:off x="7020382" y="548640"/>
+            <a:ext cx="924534" cy="45720"/>
           </a:xfrm>
           <a:prstGeom prst="rect">
             <a:avLst/>
@@ -16626,7 +18078,7 @@
                 </a:solidFill>
                 <a:latin typeface="Cascadia Mono"/>
               </a:rPr>
-              <a:t> / 11</a:t>
+              <a:t> / 12</a:t>
             </a:r>
           </a:p>
         </p:txBody>
@@ -16805,8 +18257,8 @@
         </p:nvSpPr>
         <p:spPr>
           <a:xfrm>
-            <a:off x="8617305" y="548640"/>
-            <a:ext cx="1008583" cy="45720"/>
+            <a:off x="7944916" y="548640"/>
+            <a:ext cx="924534" cy="45720"/>
           </a:xfrm>
           <a:prstGeom prst="rect">
             <a:avLst/>

</xml_diff>